<commit_message>
Apply selected NEXABio polymer-loop logo to website and poster
</commit_message>
<xml_diff>
--- a/poster/NEXABio-student-interest.pptx
+++ b/poster/NEXABio-student-interest.pptx
@@ -2,13 +2,13 @@
 <file path=ppt/presentation.xml><?xml version="1.0" encoding="utf-8"?>
 <p:presentation xmlns:p="http://schemas.openxmlformats.org/presentationml/2006/main">
   <p:sldMasterIdLst>
-    <p:sldMasterId xmlns:r="http://schemas.openxmlformats.org/officeDocument/2006/relationships" id="2147483648" r:id="Rd2f787f84c704544"/>
+    <p:sldMasterId xmlns:r="http://schemas.openxmlformats.org/officeDocument/2006/relationships" id="2147483648" r:id="R066821714fed444f"/>
   </p:sldMasterIdLst>
   <p:notesMasterIdLst>
-    <p:notesMasterId xmlns:r="http://schemas.openxmlformats.org/officeDocument/2006/relationships" r:id="Rf86692b8d4d046fe"/>
+    <p:notesMasterId xmlns:r="http://schemas.openxmlformats.org/officeDocument/2006/relationships" r:id="Rb54070806c9844c9"/>
   </p:notesMasterIdLst>
   <p:sldIdLst>
-    <p:sldId xmlns:r="http://schemas.openxmlformats.org/officeDocument/2006/relationships" id="256" r:id="Rb31010e136044340"/>
+    <p:sldId xmlns:r="http://schemas.openxmlformats.org/officeDocument/2006/relationships" id="256" r:id="R9ea429d3d35941d6"/>
   </p:sldIdLst>
   <p:sldSz cx="7772400" cy="10058400"/>
   <p:notesSz cx="6858000" cy="9144000"/>
@@ -442,7 +442,7 @@
           <a:lstStyle xmlns:a="http://schemas.openxmlformats.org/drawingml/2006/main"/>
           <a:p xmlns:a="http://schemas.openxmlformats.org/drawingml/2006/main">
             <a:r>
-              <a:t>NEXABio student recruitment draft. US Letter portrait; all text and color blocks are native editable PowerPoint shapes. Only the QR is an image.</a:t>
+              <a:t>NEXABio student recruitment draft. US Letter portrait. The selected polymer-loop logo and the QR are separate images; body text remains editable.</a:t>
             </a:r>
           </a:p>
           <a:p xmlns:a="http://schemas.openxmlformats.org/drawingml/2006/main">
@@ -463,6 +463,11 @@
           <a:p xmlns:a="http://schemas.openxmlformats.org/drawingml/2006/main">
             <a:r>
               <a:t>Form: https://forms.gle/13iPUM7vkB7HX4tK8</a:t>
+            </a:r>
+          </a:p>
+          <a:p xmlns:a="http://schemas.openxmlformats.org/drawingml/2006/main">
+            <a:r>
+              <a:t>Brand: user-selected concept B, polymer loops. Logo source and usage: public/brand/README.md.</a:t>
             </a:r>
           </a:p>
           <a:p xmlns:a="http://schemas.openxmlformats.org/drawingml/2006/main">
@@ -535,7 +540,7 @@
   </p:cSld>
   <p:clrMap bg1="lt1" tx1="dk1" bg2="lt2" tx2="dk2" accent1="accent1" accent2="accent2" accent3="accent3" accent4="accent4" accent5="accent5" accent6="accent6" hlink="hlink" folHlink="folHlink"/>
   <p:sldLayoutIdLst>
-    <p:sldLayoutId xmlns:r="http://schemas.openxmlformats.org/officeDocument/2006/relationships" id="2147483649" r:id="Rdce25729a7754071"/>
+    <p:sldLayoutId xmlns:r="http://schemas.openxmlformats.org/officeDocument/2006/relationships" id="2147483649" r:id="Ra0531066b0fb4e07"/>
   </p:sldLayoutIdLst>
   <p:txStyles>
     <p:titleStyle>
@@ -1086,7 +1091,7 @@
           <p:cNvPr id="29" name="">
             <a:extLst xmlns:a="http://schemas.openxmlformats.org/drawingml/2006/main">
               <a:ext uri="{FF2B5EF4-FFF2-40B4-BE49-F238E27FC236}">
-                <a16:creationId xmlns:a16="http://schemas.microsoft.com/office/drawing/2014/main" id="{83C00FDE-B21B-4F03-9A82-9A63741EF37C}"/>
+                <a16:creationId xmlns:a16="http://schemas.microsoft.com/office/drawing/2014/main" id="{5DEE5B1E-E386-435C-8950-055605335DFA}"/>
               </a:ext>
             </a:extLst>
           </p:cNvPr>
@@ -1116,7 +1121,7 @@
           <p:cNvPr id="2" name="">
             <a:extLst xmlns:a="http://schemas.openxmlformats.org/drawingml/2006/main">
               <a:ext uri="{FF2B5EF4-FFF2-40B4-BE49-F238E27FC236}">
-                <a16:creationId xmlns:a16="http://schemas.microsoft.com/office/drawing/2014/main" id="{9D9407FC-32B2-43FC-967B-FFF28281B838}"/>
+                <a16:creationId xmlns:a16="http://schemas.microsoft.com/office/drawing/2014/main" id="{CCD90B16-EFE8-45D5-9242-FC573181226C}"/>
               </a:ext>
             </a:extLst>
           </p:cNvPr>
@@ -1141,12 +1146,34 @@
           </a:ln>
         </p:spPr>
       </p:sp>
-      <p:sp>
-        <p:nvSpPr>
-          <p:cNvPr id="3" name="">
+      <p:pic>
+        <p:nvPicPr>
+          <p:cNvPr id="31" name=""/>
+          <p:cNvPicPr>
+            <a:picLocks xmlns:a="http://schemas.openxmlformats.org/drawingml/2006/main" noChangeAspect="1"/>
+          </p:cNvPicPr>
+          <p:nvPr/>
+        </p:nvPicPr>
+        <p:blipFill>
+          <a:blip xmlns:r="http://schemas.openxmlformats.org/officeDocument/2006/relationships" xmlns:a="http://schemas.openxmlformats.org/drawingml/2006/main" r:embed="Rde9e4c72d14b4b4a"/>
+          <a:stretch xmlns:a="http://schemas.openxmlformats.org/drawingml/2006/main"/>
+        </p:blipFill>
+        <p:spPr>
+          <a:xfrm xmlns:a="http://schemas.openxmlformats.org/drawingml/2006/main">
+            <a:off x="285750" y="152400"/>
+            <a:ext cx="2857500" cy="952500"/>
+          </a:xfrm>
+          <a:prstGeom xmlns:a="http://schemas.openxmlformats.org/drawingml/2006/main" prst="rect">
+            <a:avLst/>
+          </a:prstGeom>
+        </p:spPr>
+      </p:pic>
+      <p:sp>
+        <p:nvSpPr>
+          <p:cNvPr id="4" name="">
             <a:extLst xmlns:a="http://schemas.openxmlformats.org/drawingml/2006/main">
               <a:ext uri="{FF2B5EF4-FFF2-40B4-BE49-F238E27FC236}">
-                <a16:creationId xmlns:a16="http://schemas.microsoft.com/office/drawing/2014/main" id="{DB593268-4BF4-4984-9708-3DFBF322A4AB}"/>
+                <a16:creationId xmlns:a16="http://schemas.microsoft.com/office/drawing/2014/main" id="{6F828605-985B-4E33-B2D7-8787D00D7C8A}"/>
               </a:ext>
             </a:extLst>
           </p:cNvPr>
@@ -1157,8 +1184,8 @@
         </p:nvSpPr>
         <p:spPr>
           <a:xfrm xmlns:a="http://schemas.openxmlformats.org/drawingml/2006/main">
-            <a:off x="457200" y="333375"/>
-            <a:ext cx="3000375" cy="495300"/>
+            <a:off x="457200" y="1047750"/>
+            <a:ext cx="6572250" cy="247650"/>
           </a:xfrm>
           <a:prstGeom xmlns:a="http://schemas.openxmlformats.org/drawingml/2006/main" prst="rect">
             <a:avLst/>
@@ -1175,9 +1202,9 @@
           <a:lstStyle xmlns:a="http://schemas.openxmlformats.org/drawingml/2006/main"/>
           <a:p xmlns:a="http://schemas.openxmlformats.org/drawingml/2006/main">
             <a:pPr>
-              <a:defRPr sz="3150" b="1">
-                <a:solidFill>
-                  <a:srgbClr val="FFFFFF"/>
+              <a:defRPr sz="1425" b="0">
+                <a:solidFill>
+                  <a:srgbClr val="DDECE5"/>
                 </a:solidFill>
                 <a:latin typeface="Arial"/>
                 <a:ea typeface="Arial"/>
@@ -1185,25 +1212,25 @@
               </a:defRPr>
             </a:pPr>
             <a:r>
-              <a:rPr sz="3150" b="1">
-                <a:solidFill>
-                  <a:srgbClr val="FFFFFF"/>
+              <a:rPr sz="1425" b="0">
+                <a:solidFill>
+                  <a:srgbClr val="DDECE5"/>
                 </a:solidFill>
                 <a:latin typeface="Arial"/>
                 <a:ea typeface="Arial"/>
                 <a:cs typeface="Arial"/>
               </a:rPr>
-              <a:t>NEXABio</a:t>
+              <a:t>The University of Texas at Dallas</a:t>
             </a:r>
           </a:p>
         </p:txBody>
       </p:sp>
       <p:sp>
         <p:nvSpPr>
-          <p:cNvPr id="4" name="">
+          <p:cNvPr id="5" name="">
             <a:extLst xmlns:a="http://schemas.openxmlformats.org/drawingml/2006/main">
               <a:ext uri="{FF2B5EF4-FFF2-40B4-BE49-F238E27FC236}">
-                <a16:creationId xmlns:a16="http://schemas.microsoft.com/office/drawing/2014/main" id="{EC6E2B2F-9A2A-42A0-BCF2-00DED3197576}"/>
+                <a16:creationId xmlns:a16="http://schemas.microsoft.com/office/drawing/2014/main" id="{957DE034-2034-4C87-A327-E74400747AE1}"/>
               </a:ext>
             </a:extLst>
           </p:cNvPr>
@@ -1214,8 +1241,8 @@
         </p:nvSpPr>
         <p:spPr>
           <a:xfrm xmlns:a="http://schemas.openxmlformats.org/drawingml/2006/main">
-            <a:off x="457200" y="885825"/>
-            <a:ext cx="6572250" cy="285750"/>
+            <a:off x="457200" y="1390650"/>
+            <a:ext cx="6572250" cy="209550"/>
           </a:xfrm>
           <a:prstGeom xmlns:a="http://schemas.openxmlformats.org/drawingml/2006/main" prst="rect">
             <a:avLst/>
@@ -1232,9 +1259,9 @@
           <a:lstStyle xmlns:a="http://schemas.openxmlformats.org/drawingml/2006/main"/>
           <a:p xmlns:a="http://schemas.openxmlformats.org/drawingml/2006/main">
             <a:pPr>
-              <a:defRPr sz="1425" b="0">
-                <a:solidFill>
-                  <a:srgbClr val="DDECE5"/>
+              <a:defRPr sz="1125" b="1">
+                <a:solidFill>
+                  <a:srgbClr val="EDBF9A"/>
                 </a:solidFill>
                 <a:latin typeface="Arial"/>
                 <a:ea typeface="Arial"/>
@@ -1242,25 +1269,25 @@
               </a:defRPr>
             </a:pPr>
             <a:r>
-              <a:rPr sz="1425" b="0">
-                <a:solidFill>
-                  <a:srgbClr val="DDECE5"/>
+              <a:rPr sz="1125" b="1">
+                <a:solidFill>
+                  <a:srgbClr val="EDBF9A"/>
                 </a:solidFill>
                 <a:latin typeface="Arial"/>
                 <a:ea typeface="Arial"/>
                 <a:cs typeface="Arial"/>
               </a:rPr>
-              <a:t>The University of Texas at Dallas</a:t>
+              <a:t>STUDENT INTEREST</a:t>
             </a:r>
           </a:p>
         </p:txBody>
       </p:sp>
       <p:sp>
         <p:nvSpPr>
-          <p:cNvPr id="5" name="">
+          <p:cNvPr id="6" name="">
             <a:extLst xmlns:a="http://schemas.openxmlformats.org/drawingml/2006/main">
               <a:ext uri="{FF2B5EF4-FFF2-40B4-BE49-F238E27FC236}">
-                <a16:creationId xmlns:a16="http://schemas.microsoft.com/office/drawing/2014/main" id="{AB37B80D-2E78-45D0-A78A-EC03BB976F77}"/>
+                <a16:creationId xmlns:a16="http://schemas.microsoft.com/office/drawing/2014/main" id="{4ADF9AB5-114D-4AB0-BFD9-1989F6D946A1}"/>
               </a:ext>
             </a:extLst>
           </p:cNvPr>
@@ -1271,8 +1298,8 @@
         </p:nvSpPr>
         <p:spPr>
           <a:xfrm xmlns:a="http://schemas.openxmlformats.org/drawingml/2006/main">
-            <a:off x="457200" y="1343025"/>
-            <a:ext cx="6572250" cy="209550"/>
+            <a:off x="457200" y="1714500"/>
+            <a:ext cx="6858000" cy="1019175"/>
           </a:xfrm>
           <a:prstGeom xmlns:a="http://schemas.openxmlformats.org/drawingml/2006/main" prst="rect">
             <a:avLst/>
@@ -1289,9 +1316,9 @@
           <a:lstStyle xmlns:a="http://schemas.openxmlformats.org/drawingml/2006/main"/>
           <a:p xmlns:a="http://schemas.openxmlformats.org/drawingml/2006/main">
             <a:pPr>
-              <a:defRPr sz="1125" b="1">
-                <a:solidFill>
-                  <a:srgbClr val="EDBF9A"/>
+              <a:defRPr sz="3225" b="1">
+                <a:solidFill>
+                  <a:srgbClr val="FFFFFF"/>
                 </a:solidFill>
                 <a:latin typeface="Arial"/>
                 <a:ea typeface="Arial"/>
@@ -1299,25 +1326,48 @@
               </a:defRPr>
             </a:pPr>
             <a:r>
-              <a:rPr sz="1125" b="1">
-                <a:solidFill>
-                  <a:srgbClr val="EDBF9A"/>
+              <a:rPr sz="3225" b="1">
+                <a:solidFill>
+                  <a:srgbClr val="FFFFFF"/>
                 </a:solidFill>
                 <a:latin typeface="Arial"/>
                 <a:ea typeface="Arial"/>
                 <a:cs typeface="Arial"/>
               </a:rPr>
-              <a:t>STUDENT INTEREST</a:t>
+              <a:t>Explore AI for</a:t>
+            </a:r>
+          </a:p>
+          <a:p xmlns:a="http://schemas.openxmlformats.org/drawingml/2006/main">
+            <a:pPr>
+              <a:defRPr sz="3225" b="1">
+                <a:solidFill>
+                  <a:srgbClr val="FFFFFF"/>
+                </a:solidFill>
+                <a:latin typeface="Arial"/>
+                <a:ea typeface="Arial"/>
+                <a:cs typeface="Arial"/>
+              </a:defRPr>
+            </a:pPr>
+            <a:r>
+              <a:rPr sz="3225" b="1">
+                <a:solidFill>
+                  <a:srgbClr val="FFFFFF"/>
+                </a:solidFill>
+                <a:latin typeface="Arial"/>
+                <a:ea typeface="Arial"/>
+                <a:cs typeface="Arial"/>
+              </a:rPr>
+              <a:t>biomaterials research</a:t>
             </a:r>
           </a:p>
         </p:txBody>
       </p:sp>
       <p:sp>
         <p:nvSpPr>
-          <p:cNvPr id="6" name="">
+          <p:cNvPr id="7" name="">
             <a:extLst xmlns:a="http://schemas.openxmlformats.org/drawingml/2006/main">
               <a:ext uri="{FF2B5EF4-FFF2-40B4-BE49-F238E27FC236}">
-                <a16:creationId xmlns:a16="http://schemas.microsoft.com/office/drawing/2014/main" id="{310E8FF5-9C95-48FA-BC33-32F7970FE0F8}"/>
+                <a16:creationId xmlns:a16="http://schemas.microsoft.com/office/drawing/2014/main" id="{05BF66FF-8067-45C5-BA64-195E6DB6DD02}"/>
               </a:ext>
             </a:extLst>
           </p:cNvPr>
@@ -1328,8 +1378,8 @@
         </p:nvSpPr>
         <p:spPr>
           <a:xfrm xmlns:a="http://schemas.openxmlformats.org/drawingml/2006/main">
-            <a:off x="457200" y="1666875"/>
-            <a:ext cx="6858000" cy="1095375"/>
+            <a:off x="457200" y="2762250"/>
+            <a:ext cx="6858000" cy="438150"/>
           </a:xfrm>
           <a:prstGeom xmlns:a="http://schemas.openxmlformats.org/drawingml/2006/main" prst="rect">
             <a:avLst/>
@@ -1346,7 +1396,7 @@
           <a:lstStyle xmlns:a="http://schemas.openxmlformats.org/drawingml/2006/main"/>
           <a:p xmlns:a="http://schemas.openxmlformats.org/drawingml/2006/main">
             <a:pPr>
-              <a:defRPr sz="3225" b="1">
+              <a:defRPr sz="1350" b="0">
                 <a:solidFill>
                   <a:srgbClr val="FFFFFF"/>
                 </a:solidFill>
@@ -1356,7 +1406,7 @@
               </a:defRPr>
             </a:pPr>
             <a:r>
-              <a:rPr sz="3225" b="1">
+              <a:rPr sz="1350" b="0">
                 <a:solidFill>
                   <a:srgbClr val="FFFFFF"/>
                 </a:solidFill>
@@ -1364,40 +1414,17 @@
                 <a:ea typeface="Arial"/>
                 <a:cs typeface="Arial"/>
               </a:rPr>
-              <a:t>Explore AI for</a:t>
-            </a:r>
-          </a:p>
-          <a:p xmlns:a="http://schemas.openxmlformats.org/drawingml/2006/main">
-            <a:pPr>
-              <a:defRPr sz="3225" b="1">
-                <a:solidFill>
-                  <a:srgbClr val="FFFFFF"/>
-                </a:solidFill>
-                <a:latin typeface="Arial"/>
-                <a:ea typeface="Arial"/>
-                <a:cs typeface="Arial"/>
-              </a:defRPr>
-            </a:pPr>
-            <a:r>
-              <a:rPr sz="3225" b="1">
-                <a:solidFill>
-                  <a:srgbClr val="FFFFFF"/>
-                </a:solidFill>
-                <a:latin typeface="Arial"/>
-                <a:ea typeface="Arial"/>
-                <a:cs typeface="Arial"/>
-              </a:rPr>
-              <a:t>biomaterials research</a:t>
+              <a:t>Connect machine learning, scientific computing, and biomaterials through practical training and collaborative projects.</a:t>
             </a:r>
           </a:p>
         </p:txBody>
       </p:sp>
       <p:sp>
         <p:nvSpPr>
-          <p:cNvPr id="7" name="">
+          <p:cNvPr id="8" name="">
             <a:extLst xmlns:a="http://schemas.openxmlformats.org/drawingml/2006/main">
               <a:ext uri="{FF2B5EF4-FFF2-40B4-BE49-F238E27FC236}">
-                <a16:creationId xmlns:a16="http://schemas.microsoft.com/office/drawing/2014/main" id="{1F15E7FF-89E3-45D1-86BD-078E1FA7CE1C}"/>
+                <a16:creationId xmlns:a16="http://schemas.microsoft.com/office/drawing/2014/main" id="{3DF769E9-6A1E-468C-8123-9C1CDEE59B31}"/>
               </a:ext>
             </a:extLst>
           </p:cNvPr>
@@ -1408,8 +1435,8 @@
         </p:nvSpPr>
         <p:spPr>
           <a:xfrm xmlns:a="http://schemas.openxmlformats.org/drawingml/2006/main">
-            <a:off x="457200" y="2762250"/>
-            <a:ext cx="6858000" cy="438150"/>
+            <a:off x="457200" y="3581400"/>
+            <a:ext cx="6858000" cy="314325"/>
           </a:xfrm>
           <a:prstGeom xmlns:a="http://schemas.openxmlformats.org/drawingml/2006/main" prst="rect">
             <a:avLst/>
@@ -1426,9 +1453,9 @@
           <a:lstStyle xmlns:a="http://schemas.openxmlformats.org/drawingml/2006/main"/>
           <a:p xmlns:a="http://schemas.openxmlformats.org/drawingml/2006/main">
             <a:pPr>
-              <a:defRPr sz="1350" b="0">
-                <a:solidFill>
-                  <a:srgbClr val="FFFFFF"/>
+              <a:defRPr sz="1875" b="1">
+                <a:solidFill>
+                  <a:srgbClr val="154F43"/>
                 </a:solidFill>
                 <a:latin typeface="Arial"/>
                 <a:ea typeface="Arial"/>
@@ -1436,25 +1463,25 @@
               </a:defRPr>
             </a:pPr>
             <a:r>
-              <a:rPr sz="1350" b="0">
-                <a:solidFill>
-                  <a:srgbClr val="FFFFFF"/>
+              <a:rPr sz="1875" b="1">
+                <a:solidFill>
+                  <a:srgbClr val="154F43"/>
                 </a:solidFill>
                 <a:latin typeface="Arial"/>
                 <a:ea typeface="Arial"/>
                 <a:cs typeface="Arial"/>
               </a:rPr>
-              <a:t>Connect machine learning, scientific computing, and biomaterials through practical training and collaborative projects.</a:t>
+              <a:t>For undergraduate and graduate students</a:t>
             </a:r>
           </a:p>
         </p:txBody>
       </p:sp>
       <p:sp>
         <p:nvSpPr>
-          <p:cNvPr id="8" name="">
+          <p:cNvPr id="9" name="">
             <a:extLst xmlns:a="http://schemas.openxmlformats.org/drawingml/2006/main">
               <a:ext uri="{FF2B5EF4-FFF2-40B4-BE49-F238E27FC236}">
-                <a16:creationId xmlns:a16="http://schemas.microsoft.com/office/drawing/2014/main" id="{3058BE8C-68B4-409E-AF77-FC5B39002563}"/>
+                <a16:creationId xmlns:a16="http://schemas.microsoft.com/office/drawing/2014/main" id="{C94D0F93-30DC-4539-A5F3-5839BE54E2C9}"/>
               </a:ext>
             </a:extLst>
           </p:cNvPr>
@@ -1465,8 +1492,8 @@
         </p:nvSpPr>
         <p:spPr>
           <a:xfrm xmlns:a="http://schemas.openxmlformats.org/drawingml/2006/main">
-            <a:off x="457200" y="3581400"/>
-            <a:ext cx="6858000" cy="314325"/>
+            <a:off x="457200" y="3981450"/>
+            <a:ext cx="6858000" cy="619125"/>
           </a:xfrm>
           <a:prstGeom xmlns:a="http://schemas.openxmlformats.org/drawingml/2006/main" prst="rect">
             <a:avLst/>
@@ -1483,9 +1510,9 @@
           <a:lstStyle xmlns:a="http://schemas.openxmlformats.org/drawingml/2006/main"/>
           <a:p xmlns:a="http://schemas.openxmlformats.org/drawingml/2006/main">
             <a:pPr>
-              <a:defRPr sz="1875" b="1">
-                <a:solidFill>
-                  <a:srgbClr val="154F43"/>
+              <a:defRPr sz="1425" b="0">
+                <a:solidFill>
+                  <a:srgbClr val="50635C"/>
                 </a:solidFill>
                 <a:latin typeface="Arial"/>
                 <a:ea typeface="Arial"/>
@@ -1493,25 +1520,25 @@
               </a:defRPr>
             </a:pPr>
             <a:r>
-              <a:rPr sz="1875" b="1">
-                <a:solidFill>
-                  <a:srgbClr val="154F43"/>
+              <a:rPr sz="1425" b="0">
+                <a:solidFill>
+                  <a:srgbClr val="50635C"/>
                 </a:solidFill>
                 <a:latin typeface="Arial"/>
                 <a:ea typeface="Arial"/>
                 <a:cs typeface="Arial"/>
               </a:rPr>
-              <a:t>For undergraduate and graduate students</a:t>
+              <a:t>Bioengineering, computer science, materials science, chemistry, and related fields. Students from UT Dallas and other institutions are welcome to express interest.</a:t>
             </a:r>
           </a:p>
         </p:txBody>
       </p:sp>
       <p:sp>
         <p:nvSpPr>
-          <p:cNvPr id="9" name="">
+          <p:cNvPr id="10" name="">
             <a:extLst xmlns:a="http://schemas.openxmlformats.org/drawingml/2006/main">
               <a:ext uri="{FF2B5EF4-FFF2-40B4-BE49-F238E27FC236}">
-                <a16:creationId xmlns:a16="http://schemas.microsoft.com/office/drawing/2014/main" id="{EE7ABB41-8277-4FBB-A735-7D25375EF981}"/>
+                <a16:creationId xmlns:a16="http://schemas.microsoft.com/office/drawing/2014/main" id="{900015A6-EB71-4372-8198-5978BFBF8A6D}"/>
               </a:ext>
             </a:extLst>
           </p:cNvPr>
@@ -1522,8 +1549,8 @@
         </p:nvSpPr>
         <p:spPr>
           <a:xfrm xmlns:a="http://schemas.openxmlformats.org/drawingml/2006/main">
-            <a:off x="457200" y="3981450"/>
-            <a:ext cx="6858000" cy="619125"/>
+            <a:off x="457200" y="4810125"/>
+            <a:ext cx="6858000" cy="314325"/>
           </a:xfrm>
           <a:prstGeom xmlns:a="http://schemas.openxmlformats.org/drawingml/2006/main" prst="rect">
             <a:avLst/>
@@ -1540,9 +1567,9 @@
           <a:lstStyle xmlns:a="http://schemas.openxmlformats.org/drawingml/2006/main"/>
           <a:p xmlns:a="http://schemas.openxmlformats.org/drawingml/2006/main">
             <a:pPr>
-              <a:defRPr sz="1425" b="0">
-                <a:solidFill>
-                  <a:srgbClr val="50635C"/>
+              <a:defRPr sz="1875" b="1">
+                <a:solidFill>
+                  <a:srgbClr val="154F43"/>
                 </a:solidFill>
                 <a:latin typeface="Arial"/>
                 <a:ea typeface="Arial"/>
@@ -1550,25 +1577,25 @@
               </a:defRPr>
             </a:pPr>
             <a:r>
-              <a:rPr sz="1425" b="0">
-                <a:solidFill>
-                  <a:srgbClr val="50635C"/>
+              <a:rPr sz="1875" b="1">
+                <a:solidFill>
+                  <a:srgbClr val="154F43"/>
                 </a:solidFill>
                 <a:latin typeface="Arial"/>
                 <a:ea typeface="Arial"/>
                 <a:cs typeface="Arial"/>
               </a:rPr>
-              <a:t>Bioengineering, computer science, materials science, chemistry, and related fields. Students from UT Dallas and other institutions are welcome to express interest.</a:t>
+              <a:t>Three ways to learn and connect</a:t>
             </a:r>
           </a:p>
         </p:txBody>
       </p:sp>
       <p:sp>
         <p:nvSpPr>
-          <p:cNvPr id="10" name="">
+          <p:cNvPr id="11" name="">
             <a:extLst xmlns:a="http://schemas.openxmlformats.org/drawingml/2006/main">
               <a:ext uri="{FF2B5EF4-FFF2-40B4-BE49-F238E27FC236}">
-                <a16:creationId xmlns:a16="http://schemas.microsoft.com/office/drawing/2014/main" id="{65FC406B-2D1B-49C8-B11D-017CF1E3C027}"/>
+                <a16:creationId xmlns:a16="http://schemas.microsoft.com/office/drawing/2014/main" id="{2B587E90-8B51-40E2-9143-C0516F8261DC}"/>
               </a:ext>
             </a:extLst>
           </p:cNvPr>
@@ -1579,53 +1606,26 @@
         </p:nvSpPr>
         <p:spPr>
           <a:xfrm xmlns:a="http://schemas.openxmlformats.org/drawingml/2006/main">
-            <a:off x="457200" y="4810125"/>
-            <a:ext cx="6858000" cy="314325"/>
+            <a:off x="457200" y="5257800"/>
+            <a:ext cx="2076450" cy="28575"/>
           </a:xfrm>
           <a:prstGeom xmlns:a="http://schemas.openxmlformats.org/drawingml/2006/main" prst="rect">
             <a:avLst/>
           </a:prstGeom>
-          <a:noFill xmlns:a="http://schemas.openxmlformats.org/drawingml/2006/main"/>
+          <a:solidFill xmlns:a="http://schemas.openxmlformats.org/drawingml/2006/main">
+            <a:srgbClr val="C7602C"/>
+          </a:solidFill>
           <a:ln xmlns:a="http://schemas.openxmlformats.org/drawingml/2006/main" w="0">
             <a:noFill/>
           </a:ln>
         </p:spPr>
-        <p:txBody>
-          <a:bodyPr xmlns:a="http://schemas.openxmlformats.org/drawingml/2006/main" wrap="square" lIns="0" tIns="0" rIns="0" bIns="0" anchor="t">
-            <a:noAutofit/>
-          </a:bodyPr>
-          <a:lstStyle xmlns:a="http://schemas.openxmlformats.org/drawingml/2006/main"/>
-          <a:p xmlns:a="http://schemas.openxmlformats.org/drawingml/2006/main">
-            <a:pPr>
-              <a:defRPr sz="1875" b="1">
-                <a:solidFill>
-                  <a:srgbClr val="154F43"/>
-                </a:solidFill>
-                <a:latin typeface="Arial"/>
-                <a:ea typeface="Arial"/>
-                <a:cs typeface="Arial"/>
-              </a:defRPr>
-            </a:pPr>
-            <a:r>
-              <a:rPr sz="1875" b="1">
-                <a:solidFill>
-                  <a:srgbClr val="154F43"/>
-                </a:solidFill>
-                <a:latin typeface="Arial"/>
-                <a:ea typeface="Arial"/>
-                <a:cs typeface="Arial"/>
-              </a:rPr>
-              <a:t>Three ways to learn and connect</a:t>
-            </a:r>
-          </a:p>
-        </p:txBody>
-      </p:sp>
-      <p:sp>
-        <p:nvSpPr>
-          <p:cNvPr id="11" name="">
+      </p:sp>
+      <p:sp>
+        <p:nvSpPr>
+          <p:cNvPr id="12" name="">
             <a:extLst xmlns:a="http://schemas.openxmlformats.org/drawingml/2006/main">
               <a:ext uri="{FF2B5EF4-FFF2-40B4-BE49-F238E27FC236}">
-                <a16:creationId xmlns:a16="http://schemas.microsoft.com/office/drawing/2014/main" id="{2DF96CCE-9AF5-4A15-972A-3FFC69EB914E}"/>
+                <a16:creationId xmlns:a16="http://schemas.microsoft.com/office/drawing/2014/main" id="{7253F1A8-756A-477A-A0D0-ED6B37962B50}"/>
               </a:ext>
             </a:extLst>
           </p:cNvPr>
@@ -1636,26 +1636,53 @@
         </p:nvSpPr>
         <p:spPr>
           <a:xfrm xmlns:a="http://schemas.openxmlformats.org/drawingml/2006/main">
-            <a:off x="457200" y="5257800"/>
-            <a:ext cx="2076450" cy="28575"/>
+            <a:off x="457200" y="5429250"/>
+            <a:ext cx="2143125" cy="285750"/>
           </a:xfrm>
           <a:prstGeom xmlns:a="http://schemas.openxmlformats.org/drawingml/2006/main" prst="rect">
             <a:avLst/>
           </a:prstGeom>
-          <a:solidFill xmlns:a="http://schemas.openxmlformats.org/drawingml/2006/main">
-            <a:srgbClr val="C7602C"/>
-          </a:solidFill>
+          <a:noFill xmlns:a="http://schemas.openxmlformats.org/drawingml/2006/main"/>
           <a:ln xmlns:a="http://schemas.openxmlformats.org/drawingml/2006/main" w="0">
             <a:noFill/>
           </a:ln>
         </p:spPr>
-      </p:sp>
-      <p:sp>
-        <p:nvSpPr>
-          <p:cNvPr id="12" name="">
+        <p:txBody>
+          <a:bodyPr xmlns:a="http://schemas.openxmlformats.org/drawingml/2006/main" wrap="square" lIns="0" tIns="0" rIns="0" bIns="0" anchor="t">
+            <a:noAutofit/>
+          </a:bodyPr>
+          <a:lstStyle xmlns:a="http://schemas.openxmlformats.org/drawingml/2006/main"/>
+          <a:p xmlns:a="http://schemas.openxmlformats.org/drawingml/2006/main">
+            <a:pPr>
+              <a:defRPr sz="1500" b="1">
+                <a:solidFill>
+                  <a:srgbClr val="154F43"/>
+                </a:solidFill>
+                <a:latin typeface="Arial"/>
+                <a:ea typeface="Arial"/>
+                <a:cs typeface="Arial"/>
+              </a:defRPr>
+            </a:pPr>
+            <a:r>
+              <a:rPr sz="1500" b="1">
+                <a:solidFill>
+                  <a:srgbClr val="154F43"/>
+                </a:solidFill>
+                <a:latin typeface="Arial"/>
+                <a:ea typeface="Arial"/>
+                <a:cs typeface="Arial"/>
+              </a:rPr>
+              <a:t>Workshops</a:t>
+            </a:r>
+          </a:p>
+        </p:txBody>
+      </p:sp>
+      <p:sp>
+        <p:nvSpPr>
+          <p:cNvPr id="13" name="">
             <a:extLst xmlns:a="http://schemas.openxmlformats.org/drawingml/2006/main">
               <a:ext uri="{FF2B5EF4-FFF2-40B4-BE49-F238E27FC236}">
-                <a16:creationId xmlns:a16="http://schemas.microsoft.com/office/drawing/2014/main" id="{B18BED52-8984-46E1-A607-0F710943683F}"/>
+                <a16:creationId xmlns:a16="http://schemas.microsoft.com/office/drawing/2014/main" id="{16460CE9-A534-4855-9E6B-725C0C970ED0}"/>
               </a:ext>
             </a:extLst>
           </p:cNvPr>
@@ -1666,8 +1693,8 @@
         </p:nvSpPr>
         <p:spPr>
           <a:xfrm xmlns:a="http://schemas.openxmlformats.org/drawingml/2006/main">
-            <a:off x="457200" y="5429250"/>
-            <a:ext cx="2143125" cy="285750"/>
+            <a:off x="457200" y="5791200"/>
+            <a:ext cx="2143125" cy="523875"/>
           </a:xfrm>
           <a:prstGeom xmlns:a="http://schemas.openxmlformats.org/drawingml/2006/main" prst="rect">
             <a:avLst/>
@@ -1684,9 +1711,9 @@
           <a:lstStyle xmlns:a="http://schemas.openxmlformats.org/drawingml/2006/main"/>
           <a:p xmlns:a="http://schemas.openxmlformats.org/drawingml/2006/main">
             <a:pPr>
-              <a:defRPr sz="1500" b="1">
-                <a:solidFill>
-                  <a:srgbClr val="154F43"/>
+              <a:defRPr sz="1275" b="0">
+                <a:solidFill>
+                  <a:srgbClr val="50635C"/>
                 </a:solidFill>
                 <a:latin typeface="Arial"/>
                 <a:ea typeface="Arial"/>
@@ -1694,25 +1721,48 @@
               </a:defRPr>
             </a:pPr>
             <a:r>
-              <a:rPr sz="1500" b="1">
-                <a:solidFill>
-                  <a:srgbClr val="154F43"/>
+              <a:rPr sz="1275" b="0">
+                <a:solidFill>
+                  <a:srgbClr val="50635C"/>
                 </a:solidFill>
                 <a:latin typeface="Arial"/>
                 <a:ea typeface="Arial"/>
                 <a:cs typeface="Arial"/>
               </a:rPr>
-              <a:t>Workshops</a:t>
+              <a:t>Guided coding and</a:t>
+            </a:r>
+          </a:p>
+          <a:p xmlns:a="http://schemas.openxmlformats.org/drawingml/2006/main">
+            <a:pPr>
+              <a:defRPr sz="1275" b="0">
+                <a:solidFill>
+                  <a:srgbClr val="50635C"/>
+                </a:solidFill>
+                <a:latin typeface="Arial"/>
+                <a:ea typeface="Arial"/>
+                <a:cs typeface="Arial"/>
+              </a:defRPr>
+            </a:pPr>
+            <a:r>
+              <a:rPr sz="1275" b="0">
+                <a:solidFill>
+                  <a:srgbClr val="50635C"/>
+                </a:solidFill>
+                <a:latin typeface="Arial"/>
+                <a:ea typeface="Arial"/>
+                <a:cs typeface="Arial"/>
+              </a:rPr>
+              <a:t>hands-on mini-projects</a:t>
             </a:r>
           </a:p>
         </p:txBody>
       </p:sp>
       <p:sp>
         <p:nvSpPr>
-          <p:cNvPr id="13" name="">
+          <p:cNvPr id="14" name="">
             <a:extLst xmlns:a="http://schemas.openxmlformats.org/drawingml/2006/main">
               <a:ext uri="{FF2B5EF4-FFF2-40B4-BE49-F238E27FC236}">
-                <a16:creationId xmlns:a16="http://schemas.microsoft.com/office/drawing/2014/main" id="{D3310D34-6E70-46F0-92E7-F6F5C0E6F991}"/>
+                <a16:creationId xmlns:a16="http://schemas.microsoft.com/office/drawing/2014/main" id="{7888E092-C23A-4B3E-950E-4B907462211A}"/>
               </a:ext>
             </a:extLst>
           </p:cNvPr>
@@ -1723,76 +1773,26 @@
         </p:nvSpPr>
         <p:spPr>
           <a:xfrm xmlns:a="http://schemas.openxmlformats.org/drawingml/2006/main">
-            <a:off x="457200" y="5791200"/>
-            <a:ext cx="2143125" cy="523875"/>
+            <a:off x="2790825" y="5257800"/>
+            <a:ext cx="2076450" cy="28575"/>
           </a:xfrm>
           <a:prstGeom xmlns:a="http://schemas.openxmlformats.org/drawingml/2006/main" prst="rect">
             <a:avLst/>
           </a:prstGeom>
-          <a:noFill xmlns:a="http://schemas.openxmlformats.org/drawingml/2006/main"/>
+          <a:solidFill xmlns:a="http://schemas.openxmlformats.org/drawingml/2006/main">
+            <a:srgbClr val="C7602C"/>
+          </a:solidFill>
           <a:ln xmlns:a="http://schemas.openxmlformats.org/drawingml/2006/main" w="0">
             <a:noFill/>
           </a:ln>
         </p:spPr>
-        <p:txBody>
-          <a:bodyPr xmlns:a="http://schemas.openxmlformats.org/drawingml/2006/main" wrap="square" lIns="0" tIns="0" rIns="0" bIns="0" anchor="t">
-            <a:noAutofit/>
-          </a:bodyPr>
-          <a:lstStyle xmlns:a="http://schemas.openxmlformats.org/drawingml/2006/main"/>
-          <a:p xmlns:a="http://schemas.openxmlformats.org/drawingml/2006/main">
-            <a:pPr>
-              <a:defRPr sz="1275" b="0">
-                <a:solidFill>
-                  <a:srgbClr val="50635C"/>
-                </a:solidFill>
-                <a:latin typeface="Arial"/>
-                <a:ea typeface="Arial"/>
-                <a:cs typeface="Arial"/>
-              </a:defRPr>
-            </a:pPr>
-            <a:r>
-              <a:rPr sz="1275" b="0">
-                <a:solidFill>
-                  <a:srgbClr val="50635C"/>
-                </a:solidFill>
-                <a:latin typeface="Arial"/>
-                <a:ea typeface="Arial"/>
-                <a:cs typeface="Arial"/>
-              </a:rPr>
-              <a:t>Guided coding and</a:t>
-            </a:r>
-          </a:p>
-          <a:p xmlns:a="http://schemas.openxmlformats.org/drawingml/2006/main">
-            <a:pPr>
-              <a:defRPr sz="1275" b="0">
-                <a:solidFill>
-                  <a:srgbClr val="50635C"/>
-                </a:solidFill>
-                <a:latin typeface="Arial"/>
-                <a:ea typeface="Arial"/>
-                <a:cs typeface="Arial"/>
-              </a:defRPr>
-            </a:pPr>
-            <a:r>
-              <a:rPr sz="1275" b="0">
-                <a:solidFill>
-                  <a:srgbClr val="50635C"/>
-                </a:solidFill>
-                <a:latin typeface="Arial"/>
-                <a:ea typeface="Arial"/>
-                <a:cs typeface="Arial"/>
-              </a:rPr>
-              <a:t>hands-on mini-projects</a:t>
-            </a:r>
-          </a:p>
-        </p:txBody>
-      </p:sp>
-      <p:sp>
-        <p:nvSpPr>
-          <p:cNvPr id="14" name="">
+      </p:sp>
+      <p:sp>
+        <p:nvSpPr>
+          <p:cNvPr id="15" name="">
             <a:extLst xmlns:a="http://schemas.openxmlformats.org/drawingml/2006/main">
               <a:ext uri="{FF2B5EF4-FFF2-40B4-BE49-F238E27FC236}">
-                <a16:creationId xmlns:a16="http://schemas.microsoft.com/office/drawing/2014/main" id="{F4990646-0EC3-4C35-935C-4DE6207EA7E4}"/>
+                <a16:creationId xmlns:a16="http://schemas.microsoft.com/office/drawing/2014/main" id="{4A29537C-CD5C-4B94-8FFA-32BE94703B23}"/>
               </a:ext>
             </a:extLst>
           </p:cNvPr>
@@ -1803,26 +1803,53 @@
         </p:nvSpPr>
         <p:spPr>
           <a:xfrm xmlns:a="http://schemas.openxmlformats.org/drawingml/2006/main">
-            <a:off x="2790825" y="5257800"/>
-            <a:ext cx="2076450" cy="28575"/>
+            <a:off x="2790825" y="5429250"/>
+            <a:ext cx="2143125" cy="285750"/>
           </a:xfrm>
           <a:prstGeom xmlns:a="http://schemas.openxmlformats.org/drawingml/2006/main" prst="rect">
             <a:avLst/>
           </a:prstGeom>
-          <a:solidFill xmlns:a="http://schemas.openxmlformats.org/drawingml/2006/main">
-            <a:srgbClr val="C7602C"/>
-          </a:solidFill>
+          <a:noFill xmlns:a="http://schemas.openxmlformats.org/drawingml/2006/main"/>
           <a:ln xmlns:a="http://schemas.openxmlformats.org/drawingml/2006/main" w="0">
             <a:noFill/>
           </a:ln>
         </p:spPr>
-      </p:sp>
-      <p:sp>
-        <p:nvSpPr>
-          <p:cNvPr id="15" name="">
+        <p:txBody>
+          <a:bodyPr xmlns:a="http://schemas.openxmlformats.org/drawingml/2006/main" wrap="square" lIns="0" tIns="0" rIns="0" bIns="0" anchor="t">
+            <a:noAutofit/>
+          </a:bodyPr>
+          <a:lstStyle xmlns:a="http://schemas.openxmlformats.org/drawingml/2006/main"/>
+          <a:p xmlns:a="http://schemas.openxmlformats.org/drawingml/2006/main">
+            <a:pPr>
+              <a:defRPr sz="1500" b="1">
+                <a:solidFill>
+                  <a:srgbClr val="154F43"/>
+                </a:solidFill>
+                <a:latin typeface="Arial"/>
+                <a:ea typeface="Arial"/>
+                <a:cs typeface="Arial"/>
+              </a:defRPr>
+            </a:pPr>
+            <a:r>
+              <a:rPr sz="1500" b="1">
+                <a:solidFill>
+                  <a:srgbClr val="154F43"/>
+                </a:solidFill>
+                <a:latin typeface="Arial"/>
+                <a:ea typeface="Arial"/>
+                <a:cs typeface="Arial"/>
+              </a:rPr>
+              <a:t>Summer bootcamp</a:t>
+            </a:r>
+          </a:p>
+        </p:txBody>
+      </p:sp>
+      <p:sp>
+        <p:nvSpPr>
+          <p:cNvPr id="16" name="">
             <a:extLst xmlns:a="http://schemas.openxmlformats.org/drawingml/2006/main">
               <a:ext uri="{FF2B5EF4-FFF2-40B4-BE49-F238E27FC236}">
-                <a16:creationId xmlns:a16="http://schemas.microsoft.com/office/drawing/2014/main" id="{67D9BA4B-1231-4839-A55F-312D4A753080}"/>
+                <a16:creationId xmlns:a16="http://schemas.microsoft.com/office/drawing/2014/main" id="{C409514B-A380-45FE-A41E-95948F1B5181}"/>
               </a:ext>
             </a:extLst>
           </p:cNvPr>
@@ -1833,8 +1860,8 @@
         </p:nvSpPr>
         <p:spPr>
           <a:xfrm xmlns:a="http://schemas.openxmlformats.org/drawingml/2006/main">
-            <a:off x="2790825" y="5429250"/>
-            <a:ext cx="2143125" cy="285750"/>
+            <a:off x="2790825" y="5791200"/>
+            <a:ext cx="2143125" cy="523875"/>
           </a:xfrm>
           <a:prstGeom xmlns:a="http://schemas.openxmlformats.org/drawingml/2006/main" prst="rect">
             <a:avLst/>
@@ -1851,9 +1878,9 @@
           <a:lstStyle xmlns:a="http://schemas.openxmlformats.org/drawingml/2006/main"/>
           <a:p xmlns:a="http://schemas.openxmlformats.org/drawingml/2006/main">
             <a:pPr>
-              <a:defRPr sz="1500" b="1">
-                <a:solidFill>
-                  <a:srgbClr val="154F43"/>
+              <a:defRPr sz="1275" b="0">
+                <a:solidFill>
+                  <a:srgbClr val="50635C"/>
                 </a:solidFill>
                 <a:latin typeface="Arial"/>
                 <a:ea typeface="Arial"/>
@@ -1861,25 +1888,48 @@
               </a:defRPr>
             </a:pPr>
             <a:r>
-              <a:rPr sz="1500" b="1">
-                <a:solidFill>
-                  <a:srgbClr val="154F43"/>
+              <a:rPr sz="1275" b="0">
+                <a:solidFill>
+                  <a:srgbClr val="50635C"/>
                 </a:solidFill>
                 <a:latin typeface="Arial"/>
                 <a:ea typeface="Arial"/>
                 <a:cs typeface="Arial"/>
               </a:rPr>
-              <a:t>Summer bootcamp</a:t>
+              <a:t>An online introduction to</a:t>
+            </a:r>
+          </a:p>
+          <a:p xmlns:a="http://schemas.openxmlformats.org/drawingml/2006/main">
+            <a:pPr>
+              <a:defRPr sz="1275" b="0">
+                <a:solidFill>
+                  <a:srgbClr val="50635C"/>
+                </a:solidFill>
+                <a:latin typeface="Arial"/>
+                <a:ea typeface="Arial"/>
+                <a:cs typeface="Arial"/>
+              </a:defRPr>
+            </a:pPr>
+            <a:r>
+              <a:rPr sz="1275" b="0">
+                <a:solidFill>
+                  <a:srgbClr val="50635C"/>
+                </a:solidFill>
+                <a:latin typeface="Arial"/>
+                <a:ea typeface="Arial"/>
+                <a:cs typeface="Arial"/>
+              </a:rPr>
+              <a:t>AI-enabled biomaterials</a:t>
             </a:r>
           </a:p>
         </p:txBody>
       </p:sp>
       <p:sp>
         <p:nvSpPr>
-          <p:cNvPr id="16" name="">
+          <p:cNvPr id="17" name="">
             <a:extLst xmlns:a="http://schemas.openxmlformats.org/drawingml/2006/main">
               <a:ext uri="{FF2B5EF4-FFF2-40B4-BE49-F238E27FC236}">
-                <a16:creationId xmlns:a16="http://schemas.microsoft.com/office/drawing/2014/main" id="{C1AB06B4-7ED0-46F4-B493-C00300D1AE2E}"/>
+                <a16:creationId xmlns:a16="http://schemas.microsoft.com/office/drawing/2014/main" id="{B5A75719-974B-49E5-B59C-407C6FAE6A81}"/>
               </a:ext>
             </a:extLst>
           </p:cNvPr>
@@ -1890,76 +1940,26 @@
         </p:nvSpPr>
         <p:spPr>
           <a:xfrm xmlns:a="http://schemas.openxmlformats.org/drawingml/2006/main">
-            <a:off x="2790825" y="5791200"/>
-            <a:ext cx="2143125" cy="523875"/>
+            <a:off x="5124450" y="5257800"/>
+            <a:ext cx="2076450" cy="28575"/>
           </a:xfrm>
           <a:prstGeom xmlns:a="http://schemas.openxmlformats.org/drawingml/2006/main" prst="rect">
             <a:avLst/>
           </a:prstGeom>
-          <a:noFill xmlns:a="http://schemas.openxmlformats.org/drawingml/2006/main"/>
+          <a:solidFill xmlns:a="http://schemas.openxmlformats.org/drawingml/2006/main">
+            <a:srgbClr val="C7602C"/>
+          </a:solidFill>
           <a:ln xmlns:a="http://schemas.openxmlformats.org/drawingml/2006/main" w="0">
             <a:noFill/>
           </a:ln>
         </p:spPr>
-        <p:txBody>
-          <a:bodyPr xmlns:a="http://schemas.openxmlformats.org/drawingml/2006/main" wrap="square" lIns="0" tIns="0" rIns="0" bIns="0" anchor="t">
-            <a:noAutofit/>
-          </a:bodyPr>
-          <a:lstStyle xmlns:a="http://schemas.openxmlformats.org/drawingml/2006/main"/>
-          <a:p xmlns:a="http://schemas.openxmlformats.org/drawingml/2006/main">
-            <a:pPr>
-              <a:defRPr sz="1275" b="0">
-                <a:solidFill>
-                  <a:srgbClr val="50635C"/>
-                </a:solidFill>
-                <a:latin typeface="Arial"/>
-                <a:ea typeface="Arial"/>
-                <a:cs typeface="Arial"/>
-              </a:defRPr>
-            </a:pPr>
-            <a:r>
-              <a:rPr sz="1275" b="0">
-                <a:solidFill>
-                  <a:srgbClr val="50635C"/>
-                </a:solidFill>
-                <a:latin typeface="Arial"/>
-                <a:ea typeface="Arial"/>
-                <a:cs typeface="Arial"/>
-              </a:rPr>
-              <a:t>An online introduction to</a:t>
-            </a:r>
-          </a:p>
-          <a:p xmlns:a="http://schemas.openxmlformats.org/drawingml/2006/main">
-            <a:pPr>
-              <a:defRPr sz="1275" b="0">
-                <a:solidFill>
-                  <a:srgbClr val="50635C"/>
-                </a:solidFill>
-                <a:latin typeface="Arial"/>
-                <a:ea typeface="Arial"/>
-                <a:cs typeface="Arial"/>
-              </a:defRPr>
-            </a:pPr>
-            <a:r>
-              <a:rPr sz="1275" b="0">
-                <a:solidFill>
-                  <a:srgbClr val="50635C"/>
-                </a:solidFill>
-                <a:latin typeface="Arial"/>
-                <a:ea typeface="Arial"/>
-                <a:cs typeface="Arial"/>
-              </a:rPr>
-              <a:t>AI-enabled biomaterials</a:t>
-            </a:r>
-          </a:p>
-        </p:txBody>
-      </p:sp>
-      <p:sp>
-        <p:nvSpPr>
-          <p:cNvPr id="17" name="">
+      </p:sp>
+      <p:sp>
+        <p:nvSpPr>
+          <p:cNvPr id="18" name="">
             <a:extLst xmlns:a="http://schemas.openxmlformats.org/drawingml/2006/main">
               <a:ext uri="{FF2B5EF4-FFF2-40B4-BE49-F238E27FC236}">
-                <a16:creationId xmlns:a16="http://schemas.microsoft.com/office/drawing/2014/main" id="{88694CFE-B8E6-4DAB-A598-B5F420DA64A7}"/>
+                <a16:creationId xmlns:a16="http://schemas.microsoft.com/office/drawing/2014/main" id="{76E28BF8-34BB-4332-98B3-FB5B84BDBED1}"/>
               </a:ext>
             </a:extLst>
           </p:cNvPr>
@@ -1970,26 +1970,53 @@
         </p:nvSpPr>
         <p:spPr>
           <a:xfrm xmlns:a="http://schemas.openxmlformats.org/drawingml/2006/main">
-            <a:off x="5124450" y="5257800"/>
-            <a:ext cx="2076450" cy="28575"/>
+            <a:off x="5124450" y="5429250"/>
+            <a:ext cx="2143125" cy="285750"/>
           </a:xfrm>
           <a:prstGeom xmlns:a="http://schemas.openxmlformats.org/drawingml/2006/main" prst="rect">
             <a:avLst/>
           </a:prstGeom>
-          <a:solidFill xmlns:a="http://schemas.openxmlformats.org/drawingml/2006/main">
-            <a:srgbClr val="C7602C"/>
-          </a:solidFill>
+          <a:noFill xmlns:a="http://schemas.openxmlformats.org/drawingml/2006/main"/>
           <a:ln xmlns:a="http://schemas.openxmlformats.org/drawingml/2006/main" w="0">
             <a:noFill/>
           </a:ln>
         </p:spPr>
-      </p:sp>
-      <p:sp>
-        <p:nvSpPr>
-          <p:cNvPr id="18" name="">
+        <p:txBody>
+          <a:bodyPr xmlns:a="http://schemas.openxmlformats.org/drawingml/2006/main" wrap="square" lIns="0" tIns="0" rIns="0" bIns="0" anchor="t">
+            <a:noAutofit/>
+          </a:bodyPr>
+          <a:lstStyle xmlns:a="http://schemas.openxmlformats.org/drawingml/2006/main"/>
+          <a:p xmlns:a="http://schemas.openxmlformats.org/drawingml/2006/main">
+            <a:pPr>
+              <a:defRPr sz="1500" b="1">
+                <a:solidFill>
+                  <a:srgbClr val="154F43"/>
+                </a:solidFill>
+                <a:latin typeface="Arial"/>
+                <a:ea typeface="Arial"/>
+                <a:cs typeface="Arial"/>
+              </a:defRPr>
+            </a:pPr>
+            <a:r>
+              <a:rPr sz="1500" b="1">
+                <a:solidFill>
+                  <a:srgbClr val="154F43"/>
+                </a:solidFill>
+                <a:latin typeface="Arial"/>
+                <a:ea typeface="Arial"/>
+                <a:cs typeface="Arial"/>
+              </a:rPr>
+              <a:t>Invited talks</a:t>
+            </a:r>
+          </a:p>
+        </p:txBody>
+      </p:sp>
+      <p:sp>
+        <p:nvSpPr>
+          <p:cNvPr id="19" name="">
             <a:extLst xmlns:a="http://schemas.openxmlformats.org/drawingml/2006/main">
               <a:ext uri="{FF2B5EF4-FFF2-40B4-BE49-F238E27FC236}">
-                <a16:creationId xmlns:a16="http://schemas.microsoft.com/office/drawing/2014/main" id="{74B4B707-E57F-4EA7-B6B5-5A2D8789894C}"/>
+                <a16:creationId xmlns:a16="http://schemas.microsoft.com/office/drawing/2014/main" id="{42007828-D637-4285-A9AE-C3A8A79DDF40}"/>
               </a:ext>
             </a:extLst>
           </p:cNvPr>
@@ -2000,8 +2027,8 @@
         </p:nvSpPr>
         <p:spPr>
           <a:xfrm xmlns:a="http://schemas.openxmlformats.org/drawingml/2006/main">
-            <a:off x="5124450" y="5429250"/>
-            <a:ext cx="2143125" cy="285750"/>
+            <a:off x="5124450" y="5791200"/>
+            <a:ext cx="2143125" cy="523875"/>
           </a:xfrm>
           <a:prstGeom xmlns:a="http://schemas.openxmlformats.org/drawingml/2006/main" prst="rect">
             <a:avLst/>
@@ -2018,9 +2045,9 @@
           <a:lstStyle xmlns:a="http://schemas.openxmlformats.org/drawingml/2006/main"/>
           <a:p xmlns:a="http://schemas.openxmlformats.org/drawingml/2006/main">
             <a:pPr>
-              <a:defRPr sz="1500" b="1">
-                <a:solidFill>
-                  <a:srgbClr val="154F43"/>
+              <a:defRPr sz="1275" b="0">
+                <a:solidFill>
+                  <a:srgbClr val="50635C"/>
                 </a:solidFill>
                 <a:latin typeface="Arial"/>
                 <a:ea typeface="Arial"/>
@@ -2028,25 +2055,48 @@
               </a:defRPr>
             </a:pPr>
             <a:r>
-              <a:rPr sz="1500" b="1">
-                <a:solidFill>
-                  <a:srgbClr val="154F43"/>
+              <a:rPr sz="1275" b="0">
+                <a:solidFill>
+                  <a:srgbClr val="50635C"/>
                 </a:solidFill>
                 <a:latin typeface="Arial"/>
                 <a:ea typeface="Arial"/>
                 <a:cs typeface="Arial"/>
               </a:rPr>
-              <a:t>Invited talks</a:t>
+              <a:t>Research perspectives</a:t>
+            </a:r>
+          </a:p>
+          <a:p xmlns:a="http://schemas.openxmlformats.org/drawingml/2006/main">
+            <a:pPr>
+              <a:defRPr sz="1275" b="0">
+                <a:solidFill>
+                  <a:srgbClr val="50635C"/>
+                </a:solidFill>
+                <a:latin typeface="Arial"/>
+                <a:ea typeface="Arial"/>
+                <a:cs typeface="Arial"/>
+              </a:defRPr>
+            </a:pPr>
+            <a:r>
+              <a:rPr sz="1275" b="0">
+                <a:solidFill>
+                  <a:srgbClr val="50635C"/>
+                </a:solidFill>
+                <a:latin typeface="Arial"/>
+                <a:ea typeface="Arial"/>
+                <a:cs typeface="Arial"/>
+              </a:rPr>
+              <a:t>across AI and biomaterials</a:t>
             </a:r>
           </a:p>
         </p:txBody>
       </p:sp>
       <p:sp>
         <p:nvSpPr>
-          <p:cNvPr id="19" name="">
+          <p:cNvPr id="20" name="">
             <a:extLst xmlns:a="http://schemas.openxmlformats.org/drawingml/2006/main">
               <a:ext uri="{FF2B5EF4-FFF2-40B4-BE49-F238E27FC236}">
-                <a16:creationId xmlns:a16="http://schemas.microsoft.com/office/drawing/2014/main" id="{FFC945F4-0D7F-4A5B-AFCF-5AD39CCF428A}"/>
+                <a16:creationId xmlns:a16="http://schemas.microsoft.com/office/drawing/2014/main" id="{5BDD3D71-EB1B-47EE-A972-CBA616B04AE2}"/>
               </a:ext>
             </a:extLst>
           </p:cNvPr>
@@ -2057,8 +2107,8 @@
         </p:nvSpPr>
         <p:spPr>
           <a:xfrm xmlns:a="http://schemas.openxmlformats.org/drawingml/2006/main">
-            <a:off x="5124450" y="5791200"/>
-            <a:ext cx="2143125" cy="523875"/>
+            <a:off x="457200" y="6572250"/>
+            <a:ext cx="6858000" cy="304800"/>
           </a:xfrm>
           <a:prstGeom xmlns:a="http://schemas.openxmlformats.org/drawingml/2006/main" prst="rect">
             <a:avLst/>
@@ -2075,9 +2125,9 @@
           <a:lstStyle xmlns:a="http://schemas.openxmlformats.org/drawingml/2006/main"/>
           <a:p xmlns:a="http://schemas.openxmlformats.org/drawingml/2006/main">
             <a:pPr>
-              <a:defRPr sz="1275" b="0">
-                <a:solidFill>
-                  <a:srgbClr val="50635C"/>
+              <a:defRPr sz="1800" b="1">
+                <a:solidFill>
+                  <a:srgbClr val="154F43"/>
                 </a:solidFill>
                 <a:latin typeface="Arial"/>
                 <a:ea typeface="Arial"/>
@@ -2085,48 +2135,25 @@
               </a:defRPr>
             </a:pPr>
             <a:r>
-              <a:rPr sz="1275" b="0">
-                <a:solidFill>
-                  <a:srgbClr val="50635C"/>
+              <a:rPr sz="1800" b="1">
+                <a:solidFill>
+                  <a:srgbClr val="154F43"/>
                 </a:solidFill>
                 <a:latin typeface="Arial"/>
                 <a:ea typeface="Arial"/>
                 <a:cs typeface="Arial"/>
               </a:rPr>
-              <a:t>Research perspectives</a:t>
-            </a:r>
-          </a:p>
-          <a:p xmlns:a="http://schemas.openxmlformats.org/drawingml/2006/main">
-            <a:pPr>
-              <a:defRPr sz="1275" b="0">
-                <a:solidFill>
-                  <a:srgbClr val="50635C"/>
-                </a:solidFill>
-                <a:latin typeface="Arial"/>
-                <a:ea typeface="Arial"/>
-                <a:cs typeface="Arial"/>
-              </a:defRPr>
-            </a:pPr>
-            <a:r>
-              <a:rPr sz="1275" b="0">
-                <a:solidFill>
-                  <a:srgbClr val="50635C"/>
-                </a:solidFill>
-                <a:latin typeface="Arial"/>
-                <a:ea typeface="Arial"/>
-                <a:cs typeface="Arial"/>
-              </a:rPr>
-              <a:t>across AI and biomaterials</a:t>
+              <a:t>Explore research questions that matter</a:t>
             </a:r>
           </a:p>
         </p:txBody>
       </p:sp>
       <p:sp>
         <p:nvSpPr>
-          <p:cNvPr id="20" name="">
+          <p:cNvPr id="21" name="">
             <a:extLst xmlns:a="http://schemas.openxmlformats.org/drawingml/2006/main">
               <a:ext uri="{FF2B5EF4-FFF2-40B4-BE49-F238E27FC236}">
-                <a16:creationId xmlns:a16="http://schemas.microsoft.com/office/drawing/2014/main" id="{E6C8D668-00A9-4644-B696-774ECE74FD62}"/>
+                <a16:creationId xmlns:a16="http://schemas.microsoft.com/office/drawing/2014/main" id="{9D047A29-6ACA-47B9-934E-6A62EF5CF7C8}"/>
               </a:ext>
             </a:extLst>
           </p:cNvPr>
@@ -2137,8 +2164,8 @@
         </p:nvSpPr>
         <p:spPr>
           <a:xfrm xmlns:a="http://schemas.openxmlformats.org/drawingml/2006/main">
-            <a:off x="457200" y="6572250"/>
-            <a:ext cx="6858000" cy="304800"/>
+            <a:off x="457200" y="6981825"/>
+            <a:ext cx="6858000" cy="523875"/>
           </a:xfrm>
           <a:prstGeom xmlns:a="http://schemas.openxmlformats.org/drawingml/2006/main" prst="rect">
             <a:avLst/>
@@ -2155,9 +2182,9 @@
           <a:lstStyle xmlns:a="http://schemas.openxmlformats.org/drawingml/2006/main"/>
           <a:p xmlns:a="http://schemas.openxmlformats.org/drawingml/2006/main">
             <a:pPr>
-              <a:defRPr sz="1800" b="1">
-                <a:solidFill>
-                  <a:srgbClr val="154F43"/>
+              <a:defRPr sz="1425" b="0">
+                <a:solidFill>
+                  <a:srgbClr val="50635C"/>
                 </a:solidFill>
                 <a:latin typeface="Arial"/>
                 <a:ea typeface="Arial"/>
@@ -2165,25 +2192,48 @@
               </a:defRPr>
             </a:pPr>
             <a:r>
-              <a:rPr sz="1800" b="1">
-                <a:solidFill>
-                  <a:srgbClr val="154F43"/>
+              <a:rPr sz="1425" b="0">
+                <a:solidFill>
+                  <a:srgbClr val="50635C"/>
                 </a:solidFill>
                 <a:latin typeface="Arial"/>
                 <a:ea typeface="Arial"/>
                 <a:cs typeface="Arial"/>
               </a:rPr>
-              <a:t>Explore research questions that matter</a:t>
+              <a:t>Drug and gene delivery  /  Polymer and materials design</a:t>
+            </a:r>
+          </a:p>
+          <a:p xmlns:a="http://schemas.openxmlformats.org/drawingml/2006/main">
+            <a:pPr>
+              <a:defRPr sz="1425" b="0">
+                <a:solidFill>
+                  <a:srgbClr val="50635C"/>
+                </a:solidFill>
+                <a:latin typeface="Arial"/>
+                <a:ea typeface="Arial"/>
+                <a:cs typeface="Arial"/>
+              </a:defRPr>
+            </a:pPr>
+            <a:r>
+              <a:rPr sz="1425" b="0">
+                <a:solidFill>
+                  <a:srgbClr val="50635C"/>
+                </a:solidFill>
+                <a:latin typeface="Arial"/>
+                <a:ea typeface="Arial"/>
+                <a:cs typeface="Arial"/>
+              </a:rPr>
+              <a:t>Tissue engineering  /  Reliable AI for scientific discovery</a:t>
             </a:r>
           </a:p>
         </p:txBody>
       </p:sp>
       <p:sp>
         <p:nvSpPr>
-          <p:cNvPr id="21" name="">
+          <p:cNvPr id="22" name="">
             <a:extLst xmlns:a="http://schemas.openxmlformats.org/drawingml/2006/main">
               <a:ext uri="{FF2B5EF4-FFF2-40B4-BE49-F238E27FC236}">
-                <a16:creationId xmlns:a16="http://schemas.microsoft.com/office/drawing/2014/main" id="{91056E9B-4C60-49BA-AAF8-D1074B302567}"/>
+                <a16:creationId xmlns:a16="http://schemas.microsoft.com/office/drawing/2014/main" id="{7971E7F0-17DC-49B8-8576-17A12BDDE8CD}"/>
               </a:ext>
             </a:extLst>
           </p:cNvPr>
@@ -2194,76 +2244,26 @@
         </p:nvSpPr>
         <p:spPr>
           <a:xfrm xmlns:a="http://schemas.openxmlformats.org/drawingml/2006/main">
-            <a:off x="457200" y="6981825"/>
-            <a:ext cx="6858000" cy="523875"/>
+            <a:off x="304800" y="7724775"/>
+            <a:ext cx="7162800" cy="1724025"/>
           </a:xfrm>
           <a:prstGeom xmlns:a="http://schemas.openxmlformats.org/drawingml/2006/main" prst="rect">
             <a:avLst/>
           </a:prstGeom>
-          <a:noFill xmlns:a="http://schemas.openxmlformats.org/drawingml/2006/main"/>
+          <a:solidFill xmlns:a="http://schemas.openxmlformats.org/drawingml/2006/main">
+            <a:srgbClr val="EDF4EE"/>
+          </a:solidFill>
           <a:ln xmlns:a="http://schemas.openxmlformats.org/drawingml/2006/main" w="0">
             <a:noFill/>
           </a:ln>
         </p:spPr>
-        <p:txBody>
-          <a:bodyPr xmlns:a="http://schemas.openxmlformats.org/drawingml/2006/main" wrap="square" lIns="0" tIns="0" rIns="0" bIns="0" anchor="t">
-            <a:noAutofit/>
-          </a:bodyPr>
-          <a:lstStyle xmlns:a="http://schemas.openxmlformats.org/drawingml/2006/main"/>
-          <a:p xmlns:a="http://schemas.openxmlformats.org/drawingml/2006/main">
-            <a:pPr>
-              <a:defRPr sz="1425" b="0">
-                <a:solidFill>
-                  <a:srgbClr val="50635C"/>
-                </a:solidFill>
-                <a:latin typeface="Arial"/>
-                <a:ea typeface="Arial"/>
-                <a:cs typeface="Arial"/>
-              </a:defRPr>
-            </a:pPr>
-            <a:r>
-              <a:rPr sz="1425" b="0">
-                <a:solidFill>
-                  <a:srgbClr val="50635C"/>
-                </a:solidFill>
-                <a:latin typeface="Arial"/>
-                <a:ea typeface="Arial"/>
-                <a:cs typeface="Arial"/>
-              </a:rPr>
-              <a:t>Drug and gene delivery  /  Polymer and materials design</a:t>
-            </a:r>
-          </a:p>
-          <a:p xmlns:a="http://schemas.openxmlformats.org/drawingml/2006/main">
-            <a:pPr>
-              <a:defRPr sz="1425" b="0">
-                <a:solidFill>
-                  <a:srgbClr val="50635C"/>
-                </a:solidFill>
-                <a:latin typeface="Arial"/>
-                <a:ea typeface="Arial"/>
-                <a:cs typeface="Arial"/>
-              </a:defRPr>
-            </a:pPr>
-            <a:r>
-              <a:rPr sz="1425" b="0">
-                <a:solidFill>
-                  <a:srgbClr val="50635C"/>
-                </a:solidFill>
-                <a:latin typeface="Arial"/>
-                <a:ea typeface="Arial"/>
-                <a:cs typeface="Arial"/>
-              </a:rPr>
-              <a:t>Tissue engineering  /  Reliable AI for scientific discovery</a:t>
-            </a:r>
-          </a:p>
-        </p:txBody>
-      </p:sp>
-      <p:sp>
-        <p:nvSpPr>
-          <p:cNvPr id="22" name="">
+      </p:sp>
+      <p:sp>
+        <p:nvSpPr>
+          <p:cNvPr id="23" name="">
             <a:extLst xmlns:a="http://schemas.openxmlformats.org/drawingml/2006/main">
               <a:ext uri="{FF2B5EF4-FFF2-40B4-BE49-F238E27FC236}">
-                <a16:creationId xmlns:a16="http://schemas.microsoft.com/office/drawing/2014/main" id="{1208E23E-44C1-484C-AF68-C27EF8B7D2ED}"/>
+                <a16:creationId xmlns:a16="http://schemas.microsoft.com/office/drawing/2014/main" id="{81E7A864-FC74-4564-A984-7A2729E25941}"/>
               </a:ext>
             </a:extLst>
           </p:cNvPr>
@@ -2274,26 +2274,53 @@
         </p:nvSpPr>
         <p:spPr>
           <a:xfrm xmlns:a="http://schemas.openxmlformats.org/drawingml/2006/main">
-            <a:off x="304800" y="7724775"/>
-            <a:ext cx="7162800" cy="1724025"/>
+            <a:off x="495300" y="7924800"/>
+            <a:ext cx="4819650" cy="333375"/>
           </a:xfrm>
           <a:prstGeom xmlns:a="http://schemas.openxmlformats.org/drawingml/2006/main" prst="rect">
             <a:avLst/>
           </a:prstGeom>
-          <a:solidFill xmlns:a="http://schemas.openxmlformats.org/drawingml/2006/main">
-            <a:srgbClr val="EDF4EE"/>
-          </a:solidFill>
+          <a:noFill xmlns:a="http://schemas.openxmlformats.org/drawingml/2006/main"/>
           <a:ln xmlns:a="http://schemas.openxmlformats.org/drawingml/2006/main" w="0">
             <a:noFill/>
           </a:ln>
         </p:spPr>
-      </p:sp>
-      <p:sp>
-        <p:nvSpPr>
-          <p:cNvPr id="23" name="">
+        <p:txBody>
+          <a:bodyPr xmlns:a="http://schemas.openxmlformats.org/drawingml/2006/main" wrap="square" lIns="0" tIns="0" rIns="0" bIns="0" anchor="t">
+            <a:noAutofit/>
+          </a:bodyPr>
+          <a:lstStyle xmlns:a="http://schemas.openxmlformats.org/drawingml/2006/main"/>
+          <a:p xmlns:a="http://schemas.openxmlformats.org/drawingml/2006/main">
+            <a:pPr>
+              <a:defRPr sz="2025" b="1">
+                <a:solidFill>
+                  <a:srgbClr val="154F43"/>
+                </a:solidFill>
+                <a:latin typeface="Arial"/>
+                <a:ea typeface="Arial"/>
+                <a:cs typeface="Arial"/>
+              </a:defRPr>
+            </a:pPr>
+            <a:r>
+              <a:rPr sz="2025" b="1">
+                <a:solidFill>
+                  <a:srgbClr val="154F43"/>
+                </a:solidFill>
+                <a:latin typeface="Arial"/>
+                <a:ea typeface="Arial"/>
+                <a:cs typeface="Arial"/>
+              </a:rPr>
+              <a:t>Tell us what interests you</a:t>
+            </a:r>
+          </a:p>
+        </p:txBody>
+      </p:sp>
+      <p:sp>
+        <p:nvSpPr>
+          <p:cNvPr id="24" name="">
             <a:extLst xmlns:a="http://schemas.openxmlformats.org/drawingml/2006/main">
               <a:ext uri="{FF2B5EF4-FFF2-40B4-BE49-F238E27FC236}">
-                <a16:creationId xmlns:a16="http://schemas.microsoft.com/office/drawing/2014/main" id="{F9EC42C7-327E-48DD-8561-335B0E5A6F9E}"/>
+                <a16:creationId xmlns:a16="http://schemas.microsoft.com/office/drawing/2014/main" id="{EE34C311-7D00-4D24-BDD2-12C1EE4D0DCD}"/>
               </a:ext>
             </a:extLst>
           </p:cNvPr>
@@ -2304,8 +2331,8 @@
         </p:nvSpPr>
         <p:spPr>
           <a:xfrm xmlns:a="http://schemas.openxmlformats.org/drawingml/2006/main">
-            <a:off x="495300" y="7924800"/>
-            <a:ext cx="4819650" cy="333375"/>
+            <a:off x="495300" y="8353425"/>
+            <a:ext cx="4819650" cy="676275"/>
           </a:xfrm>
           <a:prstGeom xmlns:a="http://schemas.openxmlformats.org/drawingml/2006/main" prst="rect">
             <a:avLst/>
@@ -2322,9 +2349,9 @@
           <a:lstStyle xmlns:a="http://schemas.openxmlformats.org/drawingml/2006/main"/>
           <a:p xmlns:a="http://schemas.openxmlformats.org/drawingml/2006/main">
             <a:pPr>
-              <a:defRPr sz="2025" b="1">
-                <a:solidFill>
-                  <a:srgbClr val="154F43"/>
+              <a:defRPr sz="1350" b="0">
+                <a:solidFill>
+                  <a:srgbClr val="203B34"/>
                 </a:solidFill>
                 <a:latin typeface="Arial"/>
                 <a:ea typeface="Arial"/>
@@ -2332,25 +2359,71 @@
               </a:defRPr>
             </a:pPr>
             <a:r>
-              <a:rPr sz="2025" b="1">
-                <a:solidFill>
-                  <a:srgbClr val="154F43"/>
+              <a:rPr sz="1350" b="0">
+                <a:solidFill>
+                  <a:srgbClr val="203B34"/>
                 </a:solidFill>
                 <a:latin typeface="Arial"/>
                 <a:ea typeface="Arial"/>
                 <a:cs typeface="Arial"/>
               </a:rPr>
-              <a:t>Tell us what interests you</a:t>
+              <a:t>Scan to share your academic background,</a:t>
+            </a:r>
+          </a:p>
+          <a:p xmlns:a="http://schemas.openxmlformats.org/drawingml/2006/main">
+            <a:pPr>
+              <a:defRPr sz="1350" b="0">
+                <a:solidFill>
+                  <a:srgbClr val="203B34"/>
+                </a:solidFill>
+                <a:latin typeface="Arial"/>
+                <a:ea typeface="Arial"/>
+                <a:cs typeface="Arial"/>
+              </a:defRPr>
+            </a:pPr>
+            <a:r>
+              <a:rPr sz="1350" b="0">
+                <a:solidFill>
+                  <a:srgbClr val="203B34"/>
+                </a:solidFill>
+                <a:latin typeface="Arial"/>
+                <a:ea typeface="Arial"/>
+                <a:cs typeface="Arial"/>
+              </a:rPr>
+              <a:t>graduation plans, and research goals.</a:t>
+            </a:r>
+          </a:p>
+          <a:p xmlns:a="http://schemas.openxmlformats.org/drawingml/2006/main">
+            <a:pPr>
+              <a:defRPr sz="1350" b="0">
+                <a:solidFill>
+                  <a:srgbClr val="203B34"/>
+                </a:solidFill>
+                <a:latin typeface="Arial"/>
+                <a:ea typeface="Arial"/>
+                <a:cs typeface="Arial"/>
+              </a:defRPr>
+            </a:pPr>
+            <a:r>
+              <a:rPr sz="1350" b="0">
+                <a:solidFill>
+                  <a:srgbClr val="203B34"/>
+                </a:solidFill>
+                <a:latin typeface="Arial"/>
+                <a:ea typeface="Arial"/>
+                <a:cs typeface="Arial"/>
+              </a:rPr>
+              <a:t>12 questions · about 3-5 minutes</a:t>
             </a:r>
           </a:p>
         </p:txBody>
       </p:sp>
       <p:sp>
         <p:nvSpPr>
-          <p:cNvPr id="24" name="">
+          <p:cNvPr id="25" name="">
             <a:extLst xmlns:a="http://schemas.openxmlformats.org/drawingml/2006/main">
               <a:ext uri="{FF2B5EF4-FFF2-40B4-BE49-F238E27FC236}">
-                <a16:creationId xmlns:a16="http://schemas.microsoft.com/office/drawing/2014/main" id="{AC0E673C-ACA7-4EAB-B8A6-1E288078895D}"/>
+                <a16:creationId xmlns:a16="http://schemas.microsoft.com/office/drawing/2014/main" id="{179E81DE-1898-4A46-A59C-357DD2D3161E}"/>
               </a:ext>
             </a:extLst>
           </p:cNvPr>
@@ -2361,8 +2434,8 @@
         </p:nvSpPr>
         <p:spPr>
           <a:xfrm xmlns:a="http://schemas.openxmlformats.org/drawingml/2006/main">
-            <a:off x="495300" y="8353425"/>
-            <a:ext cx="4819650" cy="676275"/>
+            <a:off x="495300" y="9144000"/>
+            <a:ext cx="4953000" cy="219075"/>
           </a:xfrm>
           <a:prstGeom xmlns:a="http://schemas.openxmlformats.org/drawingml/2006/main" prst="rect">
             <a:avLst/>
@@ -2379,9 +2452,9 @@
           <a:lstStyle xmlns:a="http://schemas.openxmlformats.org/drawingml/2006/main"/>
           <a:p xmlns:a="http://schemas.openxmlformats.org/drawingml/2006/main">
             <a:pPr>
-              <a:defRPr sz="1350" b="0">
-                <a:solidFill>
-                  <a:srgbClr val="203B34"/>
+              <a:defRPr sz="1275" b="1">
+                <a:solidFill>
+                  <a:srgbClr val="154F43"/>
                 </a:solidFill>
                 <a:latin typeface="Arial"/>
                 <a:ea typeface="Arial"/>
@@ -2389,117 +2462,14 @@
               </a:defRPr>
             </a:pPr>
             <a:r>
-              <a:rPr sz="1350" b="0">
-                <a:solidFill>
-                  <a:srgbClr val="203B34"/>
-                </a:solidFill>
-                <a:latin typeface="Arial"/>
-                <a:ea typeface="Arial"/>
-                <a:cs typeface="Arial"/>
-              </a:rPr>
-              <a:t>Scan to share your academic background,</a:t>
-            </a:r>
-          </a:p>
-          <a:p xmlns:a="http://schemas.openxmlformats.org/drawingml/2006/main">
-            <a:pPr>
-              <a:defRPr sz="1350" b="0">
-                <a:solidFill>
-                  <a:srgbClr val="203B34"/>
-                </a:solidFill>
-                <a:latin typeface="Arial"/>
-                <a:ea typeface="Arial"/>
-                <a:cs typeface="Arial"/>
-              </a:defRPr>
-            </a:pPr>
-            <a:r>
-              <a:rPr sz="1350" b="0">
-                <a:solidFill>
-                  <a:srgbClr val="203B34"/>
-                </a:solidFill>
-                <a:latin typeface="Arial"/>
-                <a:ea typeface="Arial"/>
-                <a:cs typeface="Arial"/>
-              </a:rPr>
-              <a:t>graduation plans, and research goals.</a:t>
-            </a:r>
-          </a:p>
-          <a:p xmlns:a="http://schemas.openxmlformats.org/drawingml/2006/main">
-            <a:pPr>
-              <a:defRPr sz="1350" b="0">
-                <a:solidFill>
-                  <a:srgbClr val="203B34"/>
-                </a:solidFill>
-                <a:latin typeface="Arial"/>
-                <a:ea typeface="Arial"/>
-                <a:cs typeface="Arial"/>
-              </a:defRPr>
-            </a:pPr>
-            <a:r>
-              <a:rPr sz="1350" b="0">
-                <a:solidFill>
-                  <a:srgbClr val="203B34"/>
-                </a:solidFill>
-                <a:latin typeface="Arial"/>
-                <a:ea typeface="Arial"/>
-                <a:cs typeface="Arial"/>
-              </a:rPr>
-              <a:t>12 questions · about 3-5 minutes</a:t>
-            </a:r>
-          </a:p>
-        </p:txBody>
-      </p:sp>
-      <p:sp>
-        <p:nvSpPr>
-          <p:cNvPr id="25" name="">
-            <a:extLst xmlns:a="http://schemas.openxmlformats.org/drawingml/2006/main">
-              <a:ext uri="{FF2B5EF4-FFF2-40B4-BE49-F238E27FC236}">
-                <a16:creationId xmlns:a16="http://schemas.microsoft.com/office/drawing/2014/main" id="{587A8CFB-CD73-4C33-A831-300B17BFD70A}"/>
-              </a:ext>
-            </a:extLst>
-          </p:cNvPr>
-          <p:cNvSpPr>
-            <a:spLocks xmlns:a="http://schemas.openxmlformats.org/drawingml/2006/main" noGrp="1"/>
-          </p:cNvSpPr>
-          <p:nvPr/>
-        </p:nvSpPr>
-        <p:spPr>
-          <a:xfrm xmlns:a="http://schemas.openxmlformats.org/drawingml/2006/main">
-            <a:off x="495300" y="9144000"/>
-            <a:ext cx="4953000" cy="219075"/>
-          </a:xfrm>
-          <a:prstGeom xmlns:a="http://schemas.openxmlformats.org/drawingml/2006/main" prst="rect">
-            <a:avLst/>
-          </a:prstGeom>
-          <a:noFill xmlns:a="http://schemas.openxmlformats.org/drawingml/2006/main"/>
-          <a:ln xmlns:a="http://schemas.openxmlformats.org/drawingml/2006/main" w="0">
-            <a:noFill/>
-          </a:ln>
-        </p:spPr>
-        <p:txBody>
-          <a:bodyPr xmlns:a="http://schemas.openxmlformats.org/drawingml/2006/main" wrap="square" lIns="0" tIns="0" rIns="0" bIns="0" anchor="t">
-            <a:noAutofit/>
-          </a:bodyPr>
-          <a:lstStyle xmlns:a="http://schemas.openxmlformats.org/drawingml/2006/main"/>
-          <a:p xmlns:a="http://schemas.openxmlformats.org/drawingml/2006/main">
-            <a:pPr>
-              <a:defRPr sz="1275" b="1">
+              <a:rPr sz="1275" b="1">
                 <a:solidFill>
                   <a:srgbClr val="154F43"/>
                 </a:solidFill>
                 <a:latin typeface="Arial"/>
                 <a:ea typeface="Arial"/>
                 <a:cs typeface="Arial"/>
-              </a:defRPr>
-            </a:pPr>
-            <a:r>
-              <a:rPr sz="1275" b="1">
-                <a:solidFill>
-                  <a:srgbClr val="154F43"/>
-                </a:solidFill>
-                <a:latin typeface="Arial"/>
-                <a:ea typeface="Arial"/>
-                <a:cs typeface="Arial"/>
-                <a:hlinkClick xmlns:r="http://schemas.openxmlformats.org/officeDocument/2006/relationships" r:id="R884b83b697bb4d6c"/>
+                <a:hlinkClick xmlns:r="http://schemas.openxmlformats.org/officeDocument/2006/relationships" r:id="Rbfb14dea358b41e3"/>
               </a:rPr>
               <a:t>forms.gle/13iPUM7vkB7HX4tK8</a:t>
             </a:r>
@@ -2515,7 +2485,7 @@
           <p:nvPr/>
         </p:nvPicPr>
         <p:blipFill>
-          <a:blip xmlns:r="http://schemas.openxmlformats.org/officeDocument/2006/relationships" xmlns:a="http://schemas.openxmlformats.org/drawingml/2006/main" r:embed="R2fa1c44aa9a14a4c"/>
+          <a:blip xmlns:r="http://schemas.openxmlformats.org/officeDocument/2006/relationships" xmlns:a="http://schemas.openxmlformats.org/drawingml/2006/main" r:embed="Ra60aa7246ea64978"/>
           <a:stretch xmlns:a="http://schemas.openxmlformats.org/drawingml/2006/main"/>
         </p:blipFill>
         <p:spPr>
@@ -2533,7 +2503,7 @@
           <p:cNvPr id="27" name="">
             <a:extLst xmlns:a="http://schemas.openxmlformats.org/drawingml/2006/main">
               <a:ext uri="{FF2B5EF4-FFF2-40B4-BE49-F238E27FC236}">
-                <a16:creationId xmlns:a16="http://schemas.microsoft.com/office/drawing/2014/main" id="{4AB56077-FA01-4328-A1F3-602FDDE1B27B}"/>
+                <a16:creationId xmlns:a16="http://schemas.microsoft.com/office/drawing/2014/main" id="{ABBCCE47-8900-4B78-9A66-522DA0D55671}"/>
               </a:ext>
             </a:extLst>
           </p:cNvPr>
@@ -2590,7 +2560,7 @@
           <p:cNvPr id="28" name="">
             <a:extLst xmlns:a="http://schemas.openxmlformats.org/drawingml/2006/main">
               <a:ext uri="{FF2B5EF4-FFF2-40B4-BE49-F238E27FC236}">
-                <a16:creationId xmlns:a16="http://schemas.microsoft.com/office/drawing/2014/main" id="{26C5B7B1-B6D6-4A78-9334-855B8FAC6A34}"/>
+                <a16:creationId xmlns:a16="http://schemas.microsoft.com/office/drawing/2014/main" id="{F75462FA-04B5-4727-BABA-48CBFCC15ABE}"/>
               </a:ext>
             </a:extLst>
           </p:cNvPr>
@@ -2645,7 +2615,7 @@
     </p:spTree>
     <p:extLst>
       <p:ext uri="{BB962C8B-B14F-4D97-AF65-F5344CB8AC3E}">
-        <p14:creationId xmlns:p14="http://schemas.microsoft.com/office/powerpoint/2010/main" val="964582307"/>
+        <p14:creationId xmlns:p14="http://schemas.microsoft.com/office/powerpoint/2010/main" val="2077541347"/>
       </p:ext>
     </p:extLst>
   </p:cSld>

</xml_diff>

<commit_message>
Add biomaterials illustration to editable recruitment poster
</commit_message>
<xml_diff>
--- a/poster/NEXABio-student-interest.pptx
+++ b/poster/NEXABio-student-interest.pptx
@@ -2,13 +2,13 @@
 <file path=ppt/presentation.xml><?xml version="1.0" encoding="utf-8"?>
 <p:presentation xmlns:p="http://schemas.openxmlformats.org/presentationml/2006/main">
   <p:sldMasterIdLst>
-    <p:sldMasterId xmlns:r="http://schemas.openxmlformats.org/officeDocument/2006/relationships" id="2147483648" r:id="R066821714fed444f"/>
+    <p:sldMasterId xmlns:r="http://schemas.openxmlformats.org/officeDocument/2006/relationships" id="2147483648" r:id="R35883644abd8459f"/>
   </p:sldMasterIdLst>
   <p:notesMasterIdLst>
-    <p:notesMasterId xmlns:r="http://schemas.openxmlformats.org/officeDocument/2006/relationships" r:id="Rb54070806c9844c9"/>
+    <p:notesMasterId xmlns:r="http://schemas.openxmlformats.org/officeDocument/2006/relationships" r:id="Rea3284f51cc0457d"/>
   </p:notesMasterIdLst>
   <p:sldIdLst>
-    <p:sldId xmlns:r="http://schemas.openxmlformats.org/officeDocument/2006/relationships" id="256" r:id="R9ea429d3d35941d6"/>
+    <p:sldId xmlns:r="http://schemas.openxmlformats.org/officeDocument/2006/relationships" id="256" r:id="Re09502eeaff34279"/>
   </p:sldIdLst>
   <p:sldSz cx="7772400" cy="10058400"/>
   <p:notesSz cx="6858000" cy="9144000"/>
@@ -475,6 +475,16 @@
               <a:t>Editing instructions: poster/README.md. Changing the target form requires regenerating and replacing the QR image.</a:t>
             </a:r>
           </a:p>
+          <a:p xmlns:a="http://schemas.openxmlformats.org/drawingml/2006/main">
+            <a:r>
+              <a:t/>
+            </a:r>
+          </a:p>
+          <a:p xmlns:a="http://schemas.openxmlformats.org/drawingml/2006/main">
+            <a:r>
+              <a:t>Illustration: original AI-generated concept art shared with the NEXABio website. Source: poster/ai-biomaterials.png. Prompt and provenance: public/images/README.md and public/images/ai-biomaterials-prompt.txt. It is not an experimental result or a scientifically validated molecular model.</a:t>
+            </a:r>
+          </a:p>
         </p:txBody>
       </p:sp>
       <p:sp>
@@ -540,7 +550,7 @@
   </p:cSld>
   <p:clrMap bg1="lt1" tx1="dk1" bg2="lt2" tx2="dk2" accent1="accent1" accent2="accent2" accent3="accent3" accent4="accent4" accent5="accent5" accent6="accent6" hlink="hlink" folHlink="folHlink"/>
   <p:sldLayoutIdLst>
-    <p:sldLayoutId xmlns:r="http://schemas.openxmlformats.org/officeDocument/2006/relationships" id="2147483649" r:id="Ra0531066b0fb4e07"/>
+    <p:sldLayoutId xmlns:r="http://schemas.openxmlformats.org/officeDocument/2006/relationships" id="2147483649" r:id="Refdbdb98fd104c32"/>
   </p:sldLayoutIdLst>
   <p:txStyles>
     <p:titleStyle>
@@ -1148,14 +1158,14 @@
       </p:sp>
       <p:pic>
         <p:nvPicPr>
-          <p:cNvPr id="31" name=""/>
+          <p:cNvPr id="36" name=""/>
           <p:cNvPicPr>
             <a:picLocks xmlns:a="http://schemas.openxmlformats.org/drawingml/2006/main" noChangeAspect="1"/>
           </p:cNvPicPr>
           <p:nvPr/>
         </p:nvPicPr>
         <p:blipFill>
-          <a:blip xmlns:r="http://schemas.openxmlformats.org/officeDocument/2006/relationships" xmlns:a="http://schemas.openxmlformats.org/drawingml/2006/main" r:embed="Rde9e4c72d14b4b4a"/>
+          <a:blip xmlns:r="http://schemas.openxmlformats.org/officeDocument/2006/relationships" xmlns:a="http://schemas.openxmlformats.org/drawingml/2006/main" r:embed="R87770e8ed3a84cac"/>
           <a:stretch xmlns:a="http://schemas.openxmlformats.org/drawingml/2006/main"/>
         </p:blipFill>
         <p:spPr>
@@ -1202,6 +1212,7 @@
           <a:lstStyle xmlns:a="http://schemas.openxmlformats.org/drawingml/2006/main"/>
           <a:p xmlns:a="http://schemas.openxmlformats.org/drawingml/2006/main">
             <a:pPr>
+              <a:buNone/>
               <a:defRPr sz="1425" b="0">
                 <a:solidFill>
                   <a:srgbClr val="DDECE5"/>
@@ -1259,6 +1270,7 @@
           <a:lstStyle xmlns:a="http://schemas.openxmlformats.org/drawingml/2006/main"/>
           <a:p xmlns:a="http://schemas.openxmlformats.org/drawingml/2006/main">
             <a:pPr>
+              <a:buNone/>
               <a:defRPr sz="1125" b="1">
                 <a:solidFill>
                   <a:srgbClr val="EDBF9A"/>
@@ -1316,6 +1328,7 @@
           <a:lstStyle xmlns:a="http://schemas.openxmlformats.org/drawingml/2006/main"/>
           <a:p xmlns:a="http://schemas.openxmlformats.org/drawingml/2006/main">
             <a:pPr>
+              <a:buNone/>
               <a:defRPr sz="3225" b="1">
                 <a:solidFill>
                   <a:srgbClr val="FFFFFF"/>
@@ -1339,6 +1352,7 @@
           </a:p>
           <a:p xmlns:a="http://schemas.openxmlformats.org/drawingml/2006/main">
             <a:pPr>
+              <a:buNone/>
               <a:defRPr sz="3225" b="1">
                 <a:solidFill>
                   <a:srgbClr val="FFFFFF"/>
@@ -1396,6 +1410,7 @@
           <a:lstStyle xmlns:a="http://schemas.openxmlformats.org/drawingml/2006/main"/>
           <a:p xmlns:a="http://schemas.openxmlformats.org/drawingml/2006/main">
             <a:pPr>
+              <a:buNone/>
               <a:defRPr sz="1350" b="0">
                 <a:solidFill>
                   <a:srgbClr val="FFFFFF"/>
@@ -1435,8 +1450,8 @@
         </p:nvSpPr>
         <p:spPr>
           <a:xfrm xmlns:a="http://schemas.openxmlformats.org/drawingml/2006/main">
-            <a:off x="457200" y="3581400"/>
-            <a:ext cx="6858000" cy="314325"/>
+            <a:off x="457200" y="3571875"/>
+            <a:ext cx="4229100" cy="571500"/>
           </a:xfrm>
           <a:prstGeom xmlns:a="http://schemas.openxmlformats.org/drawingml/2006/main" prst="rect">
             <a:avLst/>
@@ -1453,7 +1468,8 @@
           <a:lstStyle xmlns:a="http://schemas.openxmlformats.org/drawingml/2006/main"/>
           <a:p xmlns:a="http://schemas.openxmlformats.org/drawingml/2006/main">
             <a:pPr>
-              <a:defRPr sz="1875" b="1">
+              <a:buNone/>
+              <a:defRPr sz="1800" b="1">
                 <a:solidFill>
                   <a:srgbClr val="154F43"/>
                 </a:solidFill>
@@ -1463,7 +1479,7 @@
               </a:defRPr>
             </a:pPr>
             <a:r>
-              <a:rPr sz="1875" b="1">
+              <a:rPr sz="1800" b="1">
                 <a:solidFill>
                   <a:srgbClr val="154F43"/>
                 </a:solidFill>
@@ -1471,7 +1487,8 @@
                 <a:ea typeface="Arial"/>
                 <a:cs typeface="Arial"/>
               </a:rPr>
-              <a:t>For undergraduate and graduate students</a:t>
+              <a:t>For undergraduate
+and graduate students</a:t>
             </a:r>
           </a:p>
         </p:txBody>
@@ -1492,8 +1509,8 @@
         </p:nvSpPr>
         <p:spPr>
           <a:xfrm xmlns:a="http://schemas.openxmlformats.org/drawingml/2006/main">
-            <a:off x="457200" y="3981450"/>
-            <a:ext cx="6858000" cy="619125"/>
+            <a:off x="457200" y="4229100"/>
+            <a:ext cx="4229100" cy="1009650"/>
           </a:xfrm>
           <a:prstGeom xmlns:a="http://schemas.openxmlformats.org/drawingml/2006/main" prst="rect">
             <a:avLst/>
@@ -1510,7 +1527,8 @@
           <a:lstStyle xmlns:a="http://schemas.openxmlformats.org/drawingml/2006/main"/>
           <a:p xmlns:a="http://schemas.openxmlformats.org/drawingml/2006/main">
             <a:pPr>
-              <a:defRPr sz="1425" b="0">
+              <a:buNone/>
+              <a:defRPr sz="1350" b="0">
                 <a:solidFill>
                   <a:srgbClr val="50635C"/>
                 </a:solidFill>
@@ -1520,7 +1538,7 @@
               </a:defRPr>
             </a:pPr>
             <a:r>
-              <a:rPr sz="1425" b="0">
+              <a:rPr sz="1350" b="0">
                 <a:solidFill>
                   <a:srgbClr val="50635C"/>
                 </a:solidFill>
@@ -1549,8 +1567,8 @@
         </p:nvSpPr>
         <p:spPr>
           <a:xfrm xmlns:a="http://schemas.openxmlformats.org/drawingml/2006/main">
-            <a:off x="457200" y="4810125"/>
-            <a:ext cx="6858000" cy="314325"/>
+            <a:off x="457200" y="5524500"/>
+            <a:ext cx="6858000" cy="285750"/>
           </a:xfrm>
           <a:prstGeom xmlns:a="http://schemas.openxmlformats.org/drawingml/2006/main" prst="rect">
             <a:avLst/>
@@ -1567,7 +1585,8 @@
           <a:lstStyle xmlns:a="http://schemas.openxmlformats.org/drawingml/2006/main"/>
           <a:p xmlns:a="http://schemas.openxmlformats.org/drawingml/2006/main">
             <a:pPr>
-              <a:defRPr sz="1875" b="1">
+              <a:buNone/>
+              <a:defRPr sz="1800" b="1">
                 <a:solidFill>
                   <a:srgbClr val="154F43"/>
                 </a:solidFill>
@@ -1577,7 +1596,7 @@
               </a:defRPr>
             </a:pPr>
             <a:r>
-              <a:rPr sz="1875" b="1">
+              <a:rPr sz="1800" b="1">
                 <a:solidFill>
                   <a:srgbClr val="154F43"/>
                 </a:solidFill>
@@ -1606,7 +1625,7 @@
         </p:nvSpPr>
         <p:spPr>
           <a:xfrm xmlns:a="http://schemas.openxmlformats.org/drawingml/2006/main">
-            <a:off x="457200" y="5257800"/>
+            <a:off x="457200" y="5953125"/>
             <a:ext cx="2076450" cy="28575"/>
           </a:xfrm>
           <a:prstGeom xmlns:a="http://schemas.openxmlformats.org/drawingml/2006/main" prst="rect">
@@ -1636,7 +1655,7 @@
         </p:nvSpPr>
         <p:spPr>
           <a:xfrm xmlns:a="http://schemas.openxmlformats.org/drawingml/2006/main">
-            <a:off x="457200" y="5429250"/>
+            <a:off x="457200" y="6124575"/>
             <a:ext cx="2143125" cy="285750"/>
           </a:xfrm>
           <a:prstGeom xmlns:a="http://schemas.openxmlformats.org/drawingml/2006/main" prst="rect">
@@ -1654,6 +1673,7 @@
           <a:lstStyle xmlns:a="http://schemas.openxmlformats.org/drawingml/2006/main"/>
           <a:p xmlns:a="http://schemas.openxmlformats.org/drawingml/2006/main">
             <a:pPr>
+              <a:buNone/>
               <a:defRPr sz="1500" b="1">
                 <a:solidFill>
                   <a:srgbClr val="154F43"/>
@@ -1693,8 +1713,8 @@
         </p:nvSpPr>
         <p:spPr>
           <a:xfrm xmlns:a="http://schemas.openxmlformats.org/drawingml/2006/main">
-            <a:off x="457200" y="5791200"/>
-            <a:ext cx="2143125" cy="523875"/>
+            <a:off x="457200" y="6477000"/>
+            <a:ext cx="2143125" cy="504825"/>
           </a:xfrm>
           <a:prstGeom xmlns:a="http://schemas.openxmlformats.org/drawingml/2006/main" prst="rect">
             <a:avLst/>
@@ -1711,6 +1731,7 @@
           <a:lstStyle xmlns:a="http://schemas.openxmlformats.org/drawingml/2006/main"/>
           <a:p xmlns:a="http://schemas.openxmlformats.org/drawingml/2006/main">
             <a:pPr>
+              <a:buNone/>
               <a:defRPr sz="1275" b="0">
                 <a:solidFill>
                   <a:srgbClr val="50635C"/>
@@ -1734,6 +1755,7 @@
           </a:p>
           <a:p xmlns:a="http://schemas.openxmlformats.org/drawingml/2006/main">
             <a:pPr>
+              <a:buNone/>
               <a:defRPr sz="1275" b="0">
                 <a:solidFill>
                   <a:srgbClr val="50635C"/>
@@ -1773,7 +1795,7 @@
         </p:nvSpPr>
         <p:spPr>
           <a:xfrm xmlns:a="http://schemas.openxmlformats.org/drawingml/2006/main">
-            <a:off x="2790825" y="5257800"/>
+            <a:off x="2790825" y="5953125"/>
             <a:ext cx="2076450" cy="28575"/>
           </a:xfrm>
           <a:prstGeom xmlns:a="http://schemas.openxmlformats.org/drawingml/2006/main" prst="rect">
@@ -1803,7 +1825,7 @@
         </p:nvSpPr>
         <p:spPr>
           <a:xfrm xmlns:a="http://schemas.openxmlformats.org/drawingml/2006/main">
-            <a:off x="2790825" y="5429250"/>
+            <a:off x="2790825" y="6124575"/>
             <a:ext cx="2143125" cy="285750"/>
           </a:xfrm>
           <a:prstGeom xmlns:a="http://schemas.openxmlformats.org/drawingml/2006/main" prst="rect">
@@ -1821,6 +1843,7 @@
           <a:lstStyle xmlns:a="http://schemas.openxmlformats.org/drawingml/2006/main"/>
           <a:p xmlns:a="http://schemas.openxmlformats.org/drawingml/2006/main">
             <a:pPr>
+              <a:buNone/>
               <a:defRPr sz="1500" b="1">
                 <a:solidFill>
                   <a:srgbClr val="154F43"/>
@@ -1860,8 +1883,8 @@
         </p:nvSpPr>
         <p:spPr>
           <a:xfrm xmlns:a="http://schemas.openxmlformats.org/drawingml/2006/main">
-            <a:off x="2790825" y="5791200"/>
-            <a:ext cx="2143125" cy="523875"/>
+            <a:off x="2790825" y="6477000"/>
+            <a:ext cx="2143125" cy="504825"/>
           </a:xfrm>
           <a:prstGeom xmlns:a="http://schemas.openxmlformats.org/drawingml/2006/main" prst="rect">
             <a:avLst/>
@@ -1878,6 +1901,7 @@
           <a:lstStyle xmlns:a="http://schemas.openxmlformats.org/drawingml/2006/main"/>
           <a:p xmlns:a="http://schemas.openxmlformats.org/drawingml/2006/main">
             <a:pPr>
+              <a:buNone/>
               <a:defRPr sz="1275" b="0">
                 <a:solidFill>
                   <a:srgbClr val="50635C"/>
@@ -1901,6 +1925,7 @@
           </a:p>
           <a:p xmlns:a="http://schemas.openxmlformats.org/drawingml/2006/main">
             <a:pPr>
+              <a:buNone/>
               <a:defRPr sz="1275" b="0">
                 <a:solidFill>
                   <a:srgbClr val="50635C"/>
@@ -1940,7 +1965,7 @@
         </p:nvSpPr>
         <p:spPr>
           <a:xfrm xmlns:a="http://schemas.openxmlformats.org/drawingml/2006/main">
-            <a:off x="5124450" y="5257800"/>
+            <a:off x="5124450" y="5953125"/>
             <a:ext cx="2076450" cy="28575"/>
           </a:xfrm>
           <a:prstGeom xmlns:a="http://schemas.openxmlformats.org/drawingml/2006/main" prst="rect">
@@ -1970,7 +1995,7 @@
         </p:nvSpPr>
         <p:spPr>
           <a:xfrm xmlns:a="http://schemas.openxmlformats.org/drawingml/2006/main">
-            <a:off x="5124450" y="5429250"/>
+            <a:off x="5124450" y="6124575"/>
             <a:ext cx="2143125" cy="285750"/>
           </a:xfrm>
           <a:prstGeom xmlns:a="http://schemas.openxmlformats.org/drawingml/2006/main" prst="rect">
@@ -1988,6 +2013,7 @@
           <a:lstStyle xmlns:a="http://schemas.openxmlformats.org/drawingml/2006/main"/>
           <a:p xmlns:a="http://schemas.openxmlformats.org/drawingml/2006/main">
             <a:pPr>
+              <a:buNone/>
               <a:defRPr sz="1500" b="1">
                 <a:solidFill>
                   <a:srgbClr val="154F43"/>
@@ -2027,8 +2053,8 @@
         </p:nvSpPr>
         <p:spPr>
           <a:xfrm xmlns:a="http://schemas.openxmlformats.org/drawingml/2006/main">
-            <a:off x="5124450" y="5791200"/>
-            <a:ext cx="2143125" cy="523875"/>
+            <a:off x="5124450" y="6477000"/>
+            <a:ext cx="2143125" cy="504825"/>
           </a:xfrm>
           <a:prstGeom xmlns:a="http://schemas.openxmlformats.org/drawingml/2006/main" prst="rect">
             <a:avLst/>
@@ -2045,6 +2071,7 @@
           <a:lstStyle xmlns:a="http://schemas.openxmlformats.org/drawingml/2006/main"/>
           <a:p xmlns:a="http://schemas.openxmlformats.org/drawingml/2006/main">
             <a:pPr>
+              <a:buNone/>
               <a:defRPr sz="1275" b="0">
                 <a:solidFill>
                   <a:srgbClr val="50635C"/>
@@ -2068,6 +2095,7 @@
           </a:p>
           <a:p xmlns:a="http://schemas.openxmlformats.org/drawingml/2006/main">
             <a:pPr>
+              <a:buNone/>
               <a:defRPr sz="1275" b="0">
                 <a:solidFill>
                   <a:srgbClr val="50635C"/>
@@ -2107,8 +2135,8 @@
         </p:nvSpPr>
         <p:spPr>
           <a:xfrm xmlns:a="http://schemas.openxmlformats.org/drawingml/2006/main">
-            <a:off x="457200" y="6572250"/>
-            <a:ext cx="6858000" cy="304800"/>
+            <a:off x="457200" y="7124700"/>
+            <a:ext cx="6858000" cy="285750"/>
           </a:xfrm>
           <a:prstGeom xmlns:a="http://schemas.openxmlformats.org/drawingml/2006/main" prst="rect">
             <a:avLst/>
@@ -2125,6 +2153,7 @@
           <a:lstStyle xmlns:a="http://schemas.openxmlformats.org/drawingml/2006/main"/>
           <a:p xmlns:a="http://schemas.openxmlformats.org/drawingml/2006/main">
             <a:pPr>
+              <a:buNone/>
               <a:defRPr sz="1800" b="1">
                 <a:solidFill>
                   <a:srgbClr val="154F43"/>
@@ -2164,8 +2193,8 @@
         </p:nvSpPr>
         <p:spPr>
           <a:xfrm xmlns:a="http://schemas.openxmlformats.org/drawingml/2006/main">
-            <a:off x="457200" y="6981825"/>
-            <a:ext cx="6858000" cy="523875"/>
+            <a:off x="457200" y="7524750"/>
+            <a:ext cx="6858000" cy="466725"/>
           </a:xfrm>
           <a:prstGeom xmlns:a="http://schemas.openxmlformats.org/drawingml/2006/main" prst="rect">
             <a:avLst/>
@@ -2182,7 +2211,8 @@
           <a:lstStyle xmlns:a="http://schemas.openxmlformats.org/drawingml/2006/main"/>
           <a:p xmlns:a="http://schemas.openxmlformats.org/drawingml/2006/main">
             <a:pPr>
-              <a:defRPr sz="1425" b="0">
+              <a:buNone/>
+              <a:defRPr sz="1350" b="0">
                 <a:solidFill>
                   <a:srgbClr val="50635C"/>
                 </a:solidFill>
@@ -2192,7 +2222,7 @@
               </a:defRPr>
             </a:pPr>
             <a:r>
-              <a:rPr sz="1425" b="0">
+              <a:rPr sz="1350" b="0">
                 <a:solidFill>
                   <a:srgbClr val="50635C"/>
                 </a:solidFill>
@@ -2205,7 +2235,8 @@
           </a:p>
           <a:p xmlns:a="http://schemas.openxmlformats.org/drawingml/2006/main">
             <a:pPr>
-              <a:defRPr sz="1425" b="0">
+              <a:buNone/>
+              <a:defRPr sz="1350" b="0">
                 <a:solidFill>
                   <a:srgbClr val="50635C"/>
                 </a:solidFill>
@@ -2215,7 +2246,7 @@
               </a:defRPr>
             </a:pPr>
             <a:r>
-              <a:rPr sz="1425" b="0">
+              <a:rPr sz="1350" b="0">
                 <a:solidFill>
                   <a:srgbClr val="50635C"/>
                 </a:solidFill>
@@ -2244,8 +2275,8 @@
         </p:nvSpPr>
         <p:spPr>
           <a:xfrm xmlns:a="http://schemas.openxmlformats.org/drawingml/2006/main">
-            <a:off x="304800" y="7724775"/>
-            <a:ext cx="7162800" cy="1724025"/>
+            <a:off x="304800" y="8096250"/>
+            <a:ext cx="7162800" cy="1352550"/>
           </a:xfrm>
           <a:prstGeom xmlns:a="http://schemas.openxmlformats.org/drawingml/2006/main" prst="rect">
             <a:avLst/>
@@ -2274,8 +2305,8 @@
         </p:nvSpPr>
         <p:spPr>
           <a:xfrm xmlns:a="http://schemas.openxmlformats.org/drawingml/2006/main">
-            <a:off x="495300" y="7924800"/>
-            <a:ext cx="4819650" cy="333375"/>
+            <a:off x="495300" y="8210550"/>
+            <a:ext cx="5238750" cy="323850"/>
           </a:xfrm>
           <a:prstGeom xmlns:a="http://schemas.openxmlformats.org/drawingml/2006/main" prst="rect">
             <a:avLst/>
@@ -2292,7 +2323,8 @@
           <a:lstStyle xmlns:a="http://schemas.openxmlformats.org/drawingml/2006/main"/>
           <a:p xmlns:a="http://schemas.openxmlformats.org/drawingml/2006/main">
             <a:pPr>
-              <a:defRPr sz="2025" b="1">
+              <a:buNone/>
+              <a:defRPr sz="1875" b="1">
                 <a:solidFill>
                   <a:srgbClr val="154F43"/>
                 </a:solidFill>
@@ -2302,7 +2334,7 @@
               </a:defRPr>
             </a:pPr>
             <a:r>
-              <a:rPr sz="2025" b="1">
+              <a:rPr sz="1875" b="1">
                 <a:solidFill>
                   <a:srgbClr val="154F43"/>
                 </a:solidFill>
@@ -2331,8 +2363,8 @@
         </p:nvSpPr>
         <p:spPr>
           <a:xfrm xmlns:a="http://schemas.openxmlformats.org/drawingml/2006/main">
-            <a:off x="495300" y="8353425"/>
-            <a:ext cx="4819650" cy="676275"/>
+            <a:off x="495300" y="8601075"/>
+            <a:ext cx="5238750" cy="552450"/>
           </a:xfrm>
           <a:prstGeom xmlns:a="http://schemas.openxmlformats.org/drawingml/2006/main" prst="rect">
             <a:avLst/>
@@ -2349,7 +2381,8 @@
           <a:lstStyle xmlns:a="http://schemas.openxmlformats.org/drawingml/2006/main"/>
           <a:p xmlns:a="http://schemas.openxmlformats.org/drawingml/2006/main">
             <a:pPr>
-              <a:defRPr sz="1350" b="0">
+              <a:buNone/>
+              <a:defRPr sz="1275" b="0">
                 <a:solidFill>
                   <a:srgbClr val="203B34"/>
                 </a:solidFill>
@@ -2359,7 +2392,7 @@
               </a:defRPr>
             </a:pPr>
             <a:r>
-              <a:rPr sz="1350" b="0">
+              <a:rPr sz="1275" b="0">
                 <a:solidFill>
                   <a:srgbClr val="203B34"/>
                 </a:solidFill>
@@ -2372,7 +2405,8 @@
           </a:p>
           <a:p xmlns:a="http://schemas.openxmlformats.org/drawingml/2006/main">
             <a:pPr>
-              <a:defRPr sz="1350" b="0">
+              <a:buNone/>
+              <a:defRPr sz="1275" b="0">
                 <a:solidFill>
                   <a:srgbClr val="203B34"/>
                 </a:solidFill>
@@ -2382,7 +2416,7 @@
               </a:defRPr>
             </a:pPr>
             <a:r>
-              <a:rPr sz="1350" b="0">
+              <a:rPr sz="1275" b="0">
                 <a:solidFill>
                   <a:srgbClr val="203B34"/>
                 </a:solidFill>
@@ -2395,7 +2429,8 @@
           </a:p>
           <a:p xmlns:a="http://schemas.openxmlformats.org/drawingml/2006/main">
             <a:pPr>
-              <a:defRPr sz="1350" b="0">
+              <a:buNone/>
+              <a:defRPr sz="1275" b="0">
                 <a:solidFill>
                   <a:srgbClr val="203B34"/>
                 </a:solidFill>
@@ -2405,7 +2440,7 @@
               </a:defRPr>
             </a:pPr>
             <a:r>
-              <a:rPr sz="1350" b="0">
+              <a:rPr sz="1275" b="0">
                 <a:solidFill>
                   <a:srgbClr val="203B34"/>
                 </a:solidFill>
@@ -2434,8 +2469,8 @@
         </p:nvSpPr>
         <p:spPr>
           <a:xfrm xmlns:a="http://schemas.openxmlformats.org/drawingml/2006/main">
-            <a:off x="495300" y="9144000"/>
-            <a:ext cx="4953000" cy="219075"/>
+            <a:off x="495300" y="9229725"/>
+            <a:ext cx="5238750" cy="209550"/>
           </a:xfrm>
           <a:prstGeom xmlns:a="http://schemas.openxmlformats.org/drawingml/2006/main" prst="rect">
             <a:avLst/>
@@ -2452,7 +2487,8 @@
           <a:lstStyle xmlns:a="http://schemas.openxmlformats.org/drawingml/2006/main"/>
           <a:p xmlns:a="http://schemas.openxmlformats.org/drawingml/2006/main">
             <a:pPr>
-              <a:defRPr sz="1275" b="1">
+              <a:buNone/>
+              <a:defRPr sz="1238" b="1">
                 <a:solidFill>
                   <a:srgbClr val="154F43"/>
                 </a:solidFill>
@@ -2462,14 +2498,14 @@
               </a:defRPr>
             </a:pPr>
             <a:r>
-              <a:rPr sz="1275" b="1">
+              <a:rPr sz="1238" b="1">
                 <a:solidFill>
                   <a:srgbClr val="154F43"/>
                 </a:solidFill>
                 <a:latin typeface="Arial"/>
                 <a:ea typeface="Arial"/>
                 <a:cs typeface="Arial"/>
-                <a:hlinkClick xmlns:r="http://schemas.openxmlformats.org/officeDocument/2006/relationships" r:id="Rbfb14dea358b41e3"/>
+                <a:hlinkClick xmlns:r="http://schemas.openxmlformats.org/officeDocument/2006/relationships" r:id="R226250cc117b4be8"/>
               </a:rPr>
               <a:t>forms.gle/13iPUM7vkB7HX4tK8</a:t>
             </a:r>
@@ -2478,20 +2514,20 @@
       </p:sp>
       <p:pic>
         <p:nvPicPr>
-          <p:cNvPr id="54" name=""/>
+          <p:cNvPr id="59" name=""/>
           <p:cNvPicPr>
             <a:picLocks xmlns:a="http://schemas.openxmlformats.org/drawingml/2006/main" noChangeAspect="1"/>
           </p:cNvPicPr>
           <p:nvPr/>
         </p:nvPicPr>
         <p:blipFill>
-          <a:blip xmlns:r="http://schemas.openxmlformats.org/officeDocument/2006/relationships" xmlns:a="http://schemas.openxmlformats.org/drawingml/2006/main" r:embed="Ra60aa7246ea64978"/>
+          <a:blip xmlns:r="http://schemas.openxmlformats.org/officeDocument/2006/relationships" xmlns:a="http://schemas.openxmlformats.org/drawingml/2006/main" r:embed="R4a5f9c02b11e4b83"/>
           <a:stretch xmlns:a="http://schemas.openxmlformats.org/drawingml/2006/main"/>
         </p:blipFill>
         <p:spPr>
           <a:xfrm xmlns:a="http://schemas.openxmlformats.org/drawingml/2006/main">
-            <a:off x="5715000" y="7896225"/>
-            <a:ext cx="1447800" cy="1447800"/>
+            <a:off x="5981700" y="8172450"/>
+            <a:ext cx="1276350" cy="1276350"/>
           </a:xfrm>
           <a:prstGeom xmlns:a="http://schemas.openxmlformats.org/drawingml/2006/main" prst="rect">
             <a:avLst/>
@@ -2532,6 +2568,7 @@
           <a:lstStyle xmlns:a="http://schemas.openxmlformats.org/drawingml/2006/main"/>
           <a:p xmlns:a="http://schemas.openxmlformats.org/drawingml/2006/main">
             <a:pPr>
+              <a:buNone/>
               <a:defRPr sz="900" b="0">
                 <a:solidFill>
                   <a:srgbClr val="50635C"/>
@@ -2589,6 +2626,7 @@
           <a:lstStyle xmlns:a="http://schemas.openxmlformats.org/drawingml/2006/main"/>
           <a:p xmlns:a="http://schemas.openxmlformats.org/drawingml/2006/main">
             <a:pPr>
+              <a:buNone/>
               <a:defRPr sz="900" b="0">
                 <a:solidFill>
                   <a:srgbClr val="50635C"/>
@@ -2608,6 +2646,85 @@
                 <a:cs typeface="Arial"/>
               </a:rPr>
               <a:t>DRAFT · Dates, eligibility, and participant support are being finalized.</a:t>
+            </a:r>
+          </a:p>
+        </p:txBody>
+      </p:sp>
+      <p:pic>
+        <p:nvPicPr>
+          <p:cNvPr id="62" name=""/>
+          <p:cNvPicPr>
+            <a:picLocks xmlns:a="http://schemas.openxmlformats.org/drawingml/2006/main" noChangeAspect="1"/>
+          </p:cNvPicPr>
+          <p:nvPr/>
+        </p:nvPicPr>
+        <p:blipFill>
+          <a:blip xmlns:r="http://schemas.openxmlformats.org/officeDocument/2006/relationships" xmlns:a="http://schemas.openxmlformats.org/drawingml/2006/main" r:embed="Ra13e438855954b6c"/>
+          <a:stretch xmlns:a="http://schemas.openxmlformats.org/drawingml/2006/main"/>
+        </p:blipFill>
+        <p:spPr>
+          <a:xfrm xmlns:a="http://schemas.openxmlformats.org/drawingml/2006/main">
+            <a:off x="4991100" y="3486150"/>
+            <a:ext cx="2324100" cy="1743075"/>
+          </a:xfrm>
+          <a:prstGeom xmlns:a="http://schemas.openxmlformats.org/drawingml/2006/main" prst="rect">
+            <a:avLst/>
+          </a:prstGeom>
+        </p:spPr>
+      </p:pic>
+      <p:sp>
+        <p:nvSpPr>
+          <p:cNvPr id="33" name="">
+            <a:extLst xmlns:a="http://schemas.openxmlformats.org/drawingml/2006/main">
+              <a:ext uri="{FF2B5EF4-FFF2-40B4-BE49-F238E27FC236}">
+                <a16:creationId xmlns:a16="http://schemas.microsoft.com/office/drawing/2014/main" id="{D16C1084-4681-427E-BE7E-8FEAC0B0D034}"/>
+              </a:ext>
+            </a:extLst>
+          </p:cNvPr>
+          <p:cNvSpPr>
+            <a:spLocks xmlns:a="http://schemas.openxmlformats.org/drawingml/2006/main" noGrp="1"/>
+          </p:cNvSpPr>
+          <p:nvPr/>
+        </p:nvSpPr>
+        <p:spPr>
+          <a:xfrm xmlns:a="http://schemas.openxmlformats.org/drawingml/2006/main">
+            <a:off x="4991100" y="5286375"/>
+            <a:ext cx="2324100" cy="161925"/>
+          </a:xfrm>
+          <a:prstGeom xmlns:a="http://schemas.openxmlformats.org/drawingml/2006/main" prst="rect">
+            <a:avLst/>
+          </a:prstGeom>
+          <a:noFill xmlns:a="http://schemas.openxmlformats.org/drawingml/2006/main"/>
+          <a:ln xmlns:a="http://schemas.openxmlformats.org/drawingml/2006/main" w="0">
+            <a:noFill/>
+          </a:ln>
+        </p:spPr>
+        <p:txBody>
+          <a:bodyPr xmlns:a="http://schemas.openxmlformats.org/drawingml/2006/main" wrap="square" lIns="0" tIns="0" rIns="0" bIns="0" anchor="t">
+            <a:noAutofit/>
+          </a:bodyPr>
+          <a:lstStyle xmlns:a="http://schemas.openxmlformats.org/drawingml/2006/main"/>
+          <a:p xmlns:a="http://schemas.openxmlformats.org/drawingml/2006/main">
+            <a:pPr>
+              <a:defRPr sz="825">
+                <a:solidFill>
+                  <a:srgbClr val="50635C"/>
+                </a:solidFill>
+                <a:latin typeface="Arial"/>
+                <a:ea typeface="Arial"/>
+                <a:cs typeface="Arial"/>
+              </a:defRPr>
+            </a:pPr>
+            <a:r>
+              <a:rPr sz="825">
+                <a:solidFill>
+                  <a:srgbClr val="50635C"/>
+                </a:solidFill>
+                <a:latin typeface="Arial"/>
+                <a:ea typeface="Arial"/>
+                <a:cs typeface="Arial"/>
+              </a:rPr>
+              <a:t>AI + biomaterials concept illustration</a:t>
             </a:r>
           </a:p>
         </p:txBody>

</xml_diff>

<commit_message>
Use selected 2D biomaterials illustration on website and poster
</commit_message>
<xml_diff>
--- a/poster/NEXABio-student-interest.pptx
+++ b/poster/NEXABio-student-interest.pptx
@@ -2,13 +2,13 @@
 <file path=ppt/presentation.xml><?xml version="1.0" encoding="utf-8"?>
 <p:presentation xmlns:p="http://schemas.openxmlformats.org/presentationml/2006/main">
   <p:sldMasterIdLst>
-    <p:sldMasterId xmlns:r="http://schemas.openxmlformats.org/officeDocument/2006/relationships" id="2147483648" r:id="R35883644abd8459f"/>
+    <p:sldMasterId xmlns:r="http://schemas.openxmlformats.org/officeDocument/2006/relationships" id="2147483648" r:id="R8d25d289632b47e9"/>
   </p:sldMasterIdLst>
   <p:notesMasterIdLst>
-    <p:notesMasterId xmlns:r="http://schemas.openxmlformats.org/officeDocument/2006/relationships" r:id="Rea3284f51cc0457d"/>
+    <p:notesMasterId xmlns:r="http://schemas.openxmlformats.org/officeDocument/2006/relationships" r:id="Rbd5b4141d060458a"/>
   </p:notesMasterIdLst>
   <p:sldIdLst>
-    <p:sldId xmlns:r="http://schemas.openxmlformats.org/officeDocument/2006/relationships" id="256" r:id="Re09502eeaff34279"/>
+    <p:sldId xmlns:r="http://schemas.openxmlformats.org/officeDocument/2006/relationships" id="256" r:id="Ref301250926040f3"/>
   </p:sldIdLst>
   <p:sldSz cx="7772400" cy="10058400"/>
   <p:notesSz cx="6858000" cy="9144000"/>
@@ -485,6 +485,16 @@
               <a:t>Illustration: original AI-generated concept art shared with the NEXABio website. Source: poster/ai-biomaterials.png. Prompt and provenance: public/images/README.md and public/images/ai-biomaterials-prompt.txt. It is not an experimental result or a scientifically validated molecular model.</a:t>
             </a:r>
           </a:p>
+          <a:p xmlns:a="http://schemas.openxmlformats.org/drawingml/2006/main">
+            <a:r>
+              <a:t/>
+            </a:r>
+          </a:p>
+          <a:p xmlns:a="http://schemas.openxmlformats.org/drawingml/2006/main">
+            <a:r>
+              <a:t>Current illustration: user-selected 2D cartoon concept C, polymer structure and drug delivery. Original PNG: poster/ai-biomaterials.png. Exact prompt: public/images/ai-biomaterials-prompt.txt. Generated with the built-in imagegen tool on September 18, 2026.</a:t>
+            </a:r>
+          </a:p>
         </p:txBody>
       </p:sp>
       <p:sp>
@@ -550,7 +560,7 @@
   </p:cSld>
   <p:clrMap bg1="lt1" tx1="dk1" bg2="lt2" tx2="dk2" accent1="accent1" accent2="accent2" accent3="accent3" accent4="accent4" accent5="accent5" accent6="accent6" hlink="hlink" folHlink="folHlink"/>
   <p:sldLayoutIdLst>
-    <p:sldLayoutId xmlns:r="http://schemas.openxmlformats.org/officeDocument/2006/relationships" id="2147483649" r:id="Refdbdb98fd104c32"/>
+    <p:sldLayoutId xmlns:r="http://schemas.openxmlformats.org/officeDocument/2006/relationships" id="2147483649" r:id="Rddb2263e448140b9"/>
   </p:sldLayoutIdLst>
   <p:txStyles>
     <p:titleStyle>
@@ -1158,14 +1168,14 @@
       </p:sp>
       <p:pic>
         <p:nvPicPr>
-          <p:cNvPr id="36" name=""/>
+          <p:cNvPr id="39" name=""/>
           <p:cNvPicPr>
             <a:picLocks xmlns:a="http://schemas.openxmlformats.org/drawingml/2006/main" noChangeAspect="1"/>
           </p:cNvPicPr>
           <p:nvPr/>
         </p:nvPicPr>
         <p:blipFill>
-          <a:blip xmlns:r="http://schemas.openxmlformats.org/officeDocument/2006/relationships" xmlns:a="http://schemas.openxmlformats.org/drawingml/2006/main" r:embed="R87770e8ed3a84cac"/>
+          <a:blip xmlns:r="http://schemas.openxmlformats.org/officeDocument/2006/relationships" xmlns:a="http://schemas.openxmlformats.org/drawingml/2006/main" r:embed="R484fdd68d8e14284"/>
           <a:stretch xmlns:a="http://schemas.openxmlformats.org/drawingml/2006/main"/>
         </p:blipFill>
         <p:spPr>
@@ -2505,7 +2515,7 @@
                 <a:latin typeface="Arial"/>
                 <a:ea typeface="Arial"/>
                 <a:cs typeface="Arial"/>
-                <a:hlinkClick xmlns:r="http://schemas.openxmlformats.org/officeDocument/2006/relationships" r:id="R226250cc117b4be8"/>
+                <a:hlinkClick xmlns:r="http://schemas.openxmlformats.org/officeDocument/2006/relationships" r:id="R2c556cece6384079"/>
               </a:rPr>
               <a:t>forms.gle/13iPUM7vkB7HX4tK8</a:t>
             </a:r>
@@ -2514,14 +2524,14 @@
       </p:sp>
       <p:pic>
         <p:nvPicPr>
-          <p:cNvPr id="59" name=""/>
+          <p:cNvPr id="62" name=""/>
           <p:cNvPicPr>
             <a:picLocks xmlns:a="http://schemas.openxmlformats.org/drawingml/2006/main" noChangeAspect="1"/>
           </p:cNvPicPr>
           <p:nvPr/>
         </p:nvPicPr>
         <p:blipFill>
-          <a:blip xmlns:r="http://schemas.openxmlformats.org/officeDocument/2006/relationships" xmlns:a="http://schemas.openxmlformats.org/drawingml/2006/main" r:embed="R4a5f9c02b11e4b83"/>
+          <a:blip xmlns:r="http://schemas.openxmlformats.org/officeDocument/2006/relationships" xmlns:a="http://schemas.openxmlformats.org/drawingml/2006/main" r:embed="Re4fcf52c975f41bc"/>
           <a:stretch xmlns:a="http://schemas.openxmlformats.org/drawingml/2006/main"/>
         </p:blipFill>
         <p:spPr>
@@ -2652,14 +2662,14 @@
       </p:sp>
       <p:pic>
         <p:nvPicPr>
-          <p:cNvPr id="62" name=""/>
+          <p:cNvPr id="65" name=""/>
           <p:cNvPicPr>
             <a:picLocks xmlns:a="http://schemas.openxmlformats.org/drawingml/2006/main" noChangeAspect="1"/>
           </p:cNvPicPr>
           <p:nvPr/>
         </p:nvPicPr>
         <p:blipFill>
-          <a:blip xmlns:r="http://schemas.openxmlformats.org/officeDocument/2006/relationships" xmlns:a="http://schemas.openxmlformats.org/drawingml/2006/main" r:embed="Ra13e438855954b6c"/>
+          <a:blip xmlns:r="http://schemas.openxmlformats.org/officeDocument/2006/relationships" xmlns:a="http://schemas.openxmlformats.org/drawingml/2006/main" r:embed="R4f144539dc654983"/>
           <a:stretch xmlns:a="http://schemas.openxmlformats.org/drawingml/2006/main"/>
         </p:blipFill>
         <p:spPr>
@@ -2706,6 +2716,7 @@
           <a:lstStyle xmlns:a="http://schemas.openxmlformats.org/drawingml/2006/main"/>
           <a:p xmlns:a="http://schemas.openxmlformats.org/drawingml/2006/main">
             <a:pPr>
+              <a:buNone/>
               <a:defRPr sz="825">
                 <a:solidFill>
                   <a:srgbClr val="50635C"/>

</xml_diff>

<commit_message>
Use student collaboration illustration in recruitment poster
</commit_message>
<xml_diff>
--- a/poster/NEXABio-student-interest.pptx
+++ b/poster/NEXABio-student-interest.pptx
@@ -2,13 +2,13 @@
 <file path=ppt/presentation.xml><?xml version="1.0" encoding="utf-8"?>
 <p:presentation xmlns:p="http://schemas.openxmlformats.org/presentationml/2006/main">
   <p:sldMasterIdLst>
-    <p:sldMasterId xmlns:r="http://schemas.openxmlformats.org/officeDocument/2006/relationships" id="2147483648" r:id="R8d25d289632b47e9"/>
+    <p:sldMasterId xmlns:r="http://schemas.openxmlformats.org/officeDocument/2006/relationships" id="2147483648" r:id="R7fb52ec406ec4478"/>
   </p:sldMasterIdLst>
   <p:notesMasterIdLst>
-    <p:notesMasterId xmlns:r="http://schemas.openxmlformats.org/officeDocument/2006/relationships" r:id="Rbd5b4141d060458a"/>
+    <p:notesMasterId xmlns:r="http://schemas.openxmlformats.org/officeDocument/2006/relationships" r:id="R402e39200f9b4965"/>
   </p:notesMasterIdLst>
   <p:sldIdLst>
-    <p:sldId xmlns:r="http://schemas.openxmlformats.org/officeDocument/2006/relationships" id="256" r:id="Ref301250926040f3"/>
+    <p:sldId xmlns:r="http://schemas.openxmlformats.org/officeDocument/2006/relationships" id="256" r:id="R6c82f30ff6334363"/>
   </p:sldIdLst>
   <p:sldSz cx="7772400" cy="10058400"/>
   <p:notesSz cx="6858000" cy="9144000"/>
@@ -442,7 +442,7 @@
           <a:lstStyle xmlns:a="http://schemas.openxmlformats.org/drawingml/2006/main"/>
           <a:p xmlns:a="http://schemas.openxmlformats.org/drawingml/2006/main">
             <a:r>
-              <a:t>NEXABio student recruitment draft. US Letter portrait. The selected polymer-loop logo and the QR are separate images; body text remains editable.</a:t>
+              <a:t>NEXABio student recruitment draft. US Letter portrait. The selected polymer-loop logo, student collaboration illustration, and QR are separate images; body text remains editable.</a:t>
             </a:r>
           </a:p>
           <a:p xmlns:a="http://schemas.openxmlformats.org/drawingml/2006/main">
@@ -477,22 +477,7 @@
           </a:p>
           <a:p xmlns:a="http://schemas.openxmlformats.org/drawingml/2006/main">
             <a:r>
-              <a:t/>
-            </a:r>
-          </a:p>
-          <a:p xmlns:a="http://schemas.openxmlformats.org/drawingml/2006/main">
-            <a:r>
-              <a:t>Illustration: original AI-generated concept art shared with the NEXABio website. Source: poster/ai-biomaterials.png. Prompt and provenance: public/images/README.md and public/images/ai-biomaterials-prompt.txt. It is not an experimental result or a scientifically validated molecular model.</a:t>
-            </a:r>
-          </a:p>
-          <a:p xmlns:a="http://schemas.openxmlformats.org/drawingml/2006/main">
-            <a:r>
-              <a:t/>
-            </a:r>
-          </a:p>
-          <a:p xmlns:a="http://schemas.openxmlformats.org/drawingml/2006/main">
-            <a:r>
-              <a:t>Current illustration: user-selected 2D cartoon concept C, polymer structure and drug delivery. Original PNG: poster/ai-biomaterials.png. Exact prompt: public/images/ai-biomaterials-prompt.txt. Generated with the built-in imagegen tool on September 18, 2026.</a:t>
+              <a:t>Illustration: three fictional students collaborating on AI and biomaterials, selected by the project owner. Generated with the built-in imagegen tool on September 18, 2026. Original PNG shared with the website: public/images/student-collaboration.png. Exact prompt: public/images/student-collaboration-prompt.txt. Provenance: public/images/README.md. This is an illustration, not a photograph of actual participants or faculty.</a:t>
             </a:r>
           </a:p>
         </p:txBody>
@@ -560,7 +545,7 @@
   </p:cSld>
   <p:clrMap bg1="lt1" tx1="dk1" bg2="lt2" tx2="dk2" accent1="accent1" accent2="accent2" accent3="accent3" accent4="accent4" accent5="accent5" accent6="accent6" hlink="hlink" folHlink="folHlink"/>
   <p:sldLayoutIdLst>
-    <p:sldLayoutId xmlns:r="http://schemas.openxmlformats.org/officeDocument/2006/relationships" id="2147483649" r:id="Rddb2263e448140b9"/>
+    <p:sldLayoutId xmlns:r="http://schemas.openxmlformats.org/officeDocument/2006/relationships" id="2147483649" r:id="R88b5aeb4d3324a1f"/>
   </p:sldLayoutIdLst>
   <p:txStyles>
     <p:titleStyle>
@@ -1175,7 +1160,7 @@
           <p:nvPr/>
         </p:nvPicPr>
         <p:blipFill>
-          <a:blip xmlns:r="http://schemas.openxmlformats.org/officeDocument/2006/relationships" xmlns:a="http://schemas.openxmlformats.org/drawingml/2006/main" r:embed="R484fdd68d8e14284"/>
+          <a:blip xmlns:r="http://schemas.openxmlformats.org/officeDocument/2006/relationships" xmlns:a="http://schemas.openxmlformats.org/drawingml/2006/main" r:embed="R3c873f9775b04be4"/>
           <a:stretch xmlns:a="http://schemas.openxmlformats.org/drawingml/2006/main"/>
         </p:blipFill>
         <p:spPr>
@@ -2515,7 +2500,7 @@
                 <a:latin typeface="Arial"/>
                 <a:ea typeface="Arial"/>
                 <a:cs typeface="Arial"/>
-                <a:hlinkClick xmlns:r="http://schemas.openxmlformats.org/officeDocument/2006/relationships" r:id="R2c556cece6384079"/>
+                <a:hlinkClick xmlns:r="http://schemas.openxmlformats.org/officeDocument/2006/relationships" r:id="Rdcfcaef8cda84794"/>
               </a:rPr>
               <a:t>forms.gle/13iPUM7vkB7HX4tK8</a:t>
             </a:r>
@@ -2531,7 +2516,7 @@
           <p:nvPr/>
         </p:nvPicPr>
         <p:blipFill>
-          <a:blip xmlns:r="http://schemas.openxmlformats.org/officeDocument/2006/relationships" xmlns:a="http://schemas.openxmlformats.org/drawingml/2006/main" r:embed="Re4fcf52c975f41bc"/>
+          <a:blip xmlns:r="http://schemas.openxmlformats.org/officeDocument/2006/relationships" xmlns:a="http://schemas.openxmlformats.org/drawingml/2006/main" r:embed="R0774efbd83d6482d"/>
           <a:stretch xmlns:a="http://schemas.openxmlformats.org/drawingml/2006/main"/>
         </p:blipFill>
         <p:spPr>
@@ -2669,7 +2654,7 @@
           <p:nvPr/>
         </p:nvPicPr>
         <p:blipFill>
-          <a:blip xmlns:r="http://schemas.openxmlformats.org/officeDocument/2006/relationships" xmlns:a="http://schemas.openxmlformats.org/drawingml/2006/main" r:embed="R4f144539dc654983"/>
+          <a:blip xmlns:r="http://schemas.openxmlformats.org/officeDocument/2006/relationships" xmlns:a="http://schemas.openxmlformats.org/drawingml/2006/main" r:embed="R7c121bb05d694db4"/>
           <a:stretch xmlns:a="http://schemas.openxmlformats.org/drawingml/2006/main"/>
         </p:blipFill>
         <p:spPr>
@@ -2735,7 +2720,7 @@
                 <a:ea typeface="Arial"/>
                 <a:cs typeface="Arial"/>
               </a:rPr>
-              <a:t>AI + biomaterials concept illustration</a:t>
+              <a:t>Student collaboration illustration</a:t>
             </a:r>
           </a:p>
         </p:txBody>

</xml_diff>

<commit_message>
Highlight compensation for confirmed student participants
</commit_message>
<xml_diff>
--- a/poster/NEXABio-student-interest.pptx
+++ b/poster/NEXABio-student-interest.pptx
@@ -2,13 +2,13 @@
 <file path=ppt/presentation.xml><?xml version="1.0" encoding="utf-8"?>
 <p:presentation xmlns:p="http://schemas.openxmlformats.org/presentationml/2006/main">
   <p:sldMasterIdLst>
-    <p:sldMasterId xmlns:r="http://schemas.openxmlformats.org/officeDocument/2006/relationships" id="2147483648" r:id="R7fb52ec406ec4478"/>
+    <p:sldMasterId xmlns:r="http://schemas.openxmlformats.org/officeDocument/2006/relationships" id="2147483648" r:id="R2aceffb5dfba4645"/>
   </p:sldMasterIdLst>
   <p:notesMasterIdLst>
-    <p:notesMasterId xmlns:r="http://schemas.openxmlformats.org/officeDocument/2006/relationships" r:id="R402e39200f9b4965"/>
+    <p:notesMasterId xmlns:r="http://schemas.openxmlformats.org/officeDocument/2006/relationships" r:id="Re3eeba5affea4cbd"/>
   </p:notesMasterIdLst>
   <p:sldIdLst>
-    <p:sldId xmlns:r="http://schemas.openxmlformats.org/officeDocument/2006/relationships" id="256" r:id="R6c82f30ff6334363"/>
+    <p:sldId xmlns:r="http://schemas.openxmlformats.org/officeDocument/2006/relationships" id="256" r:id="Ra86a95f9e3674f7a"/>
   </p:sldIdLst>
   <p:sldSz cx="7772400" cy="10058400"/>
   <p:notesSz cx="6858000" cy="9144000"/>
@@ -457,7 +457,7 @@
           </a:p>
           <a:p xmlns:a="http://schemas.openxmlformats.org/drawingml/2006/main">
             <a:r>
-              <a:t>Dates, eligibility, funding acknowledgment, and participant support are unconfirmed. No award, stipend, or enrollment guarantee is made.</a:t>
+              <a:t>The project owner confirmed that students with successful, confirmed program registration will receive compensation. The amount and payment details have not been specified. Dates, eligibility, and formal funding acknowledgment remain unconfirmed; the interest form is not enrollment confirmation.</a:t>
             </a:r>
           </a:p>
           <a:p xmlns:a="http://schemas.openxmlformats.org/drawingml/2006/main">
@@ -478,6 +478,11 @@
           <a:p xmlns:a="http://schemas.openxmlformats.org/drawingml/2006/main">
             <a:r>
               <a:t>Illustration: three fictional students collaborating on AI and biomaterials, selected by the project owner. Generated with the built-in imagegen tool on September 18, 2026. Original PNG shared with the website: public/images/student-collaboration.png. Exact prompt: public/images/student-collaboration-prompt.txt. Provenance: public/images/README.md. This is an illustration, not a photograph of actual participants or faculty.</a:t>
+            </a:r>
+          </a:p>
+          <a:p xmlns:a="http://schemas.openxmlformats.org/drawingml/2006/main">
+            <a:r>
+              <a:t/>
             </a:r>
           </a:p>
         </p:txBody>
@@ -545,7 +550,7 @@
   </p:cSld>
   <p:clrMap bg1="lt1" tx1="dk1" bg2="lt2" tx2="dk2" accent1="accent1" accent2="accent2" accent3="accent3" accent4="accent4" accent5="accent5" accent6="accent6" hlink="hlink" folHlink="folHlink"/>
   <p:sldLayoutIdLst>
-    <p:sldLayoutId xmlns:r="http://schemas.openxmlformats.org/officeDocument/2006/relationships" id="2147483649" r:id="R88b5aeb4d3324a1f"/>
+    <p:sldLayoutId xmlns:r="http://schemas.openxmlformats.org/officeDocument/2006/relationships" id="2147483649" r:id="R70c6868917a6477e"/>
   </p:sldLayoutIdLst>
   <p:txStyles>
     <p:titleStyle>
@@ -1160,7 +1165,7 @@
           <p:nvPr/>
         </p:nvPicPr>
         <p:blipFill>
-          <a:blip xmlns:r="http://schemas.openxmlformats.org/officeDocument/2006/relationships" xmlns:a="http://schemas.openxmlformats.org/drawingml/2006/main" r:embed="R3c873f9775b04be4"/>
+          <a:blip xmlns:r="http://schemas.openxmlformats.org/officeDocument/2006/relationships" xmlns:a="http://schemas.openxmlformats.org/drawingml/2006/main" r:embed="Re1a1883fe37c456c"/>
           <a:stretch xmlns:a="http://schemas.openxmlformats.org/drawingml/2006/main"/>
         </p:blipFill>
         <p:spPr>
@@ -1247,28 +1252,30 @@
         </p:nvSpPr>
         <p:spPr>
           <a:xfrm xmlns:a="http://schemas.openxmlformats.org/drawingml/2006/main">
-            <a:off x="457200" y="1390650"/>
-            <a:ext cx="6572250" cy="209550"/>
+            <a:off x="457200" y="1352550"/>
+            <a:ext cx="6858000" cy="295275"/>
           </a:xfrm>
           <a:prstGeom xmlns:a="http://schemas.openxmlformats.org/drawingml/2006/main" prst="rect">
             <a:avLst/>
           </a:prstGeom>
-          <a:noFill xmlns:a="http://schemas.openxmlformats.org/drawingml/2006/main"/>
+          <a:solidFill xmlns:a="http://schemas.openxmlformats.org/drawingml/2006/main">
+            <a:srgbClr val="F1BD91"/>
+          </a:solidFill>
           <a:ln xmlns:a="http://schemas.openxmlformats.org/drawingml/2006/main" w="0">
             <a:noFill/>
           </a:ln>
         </p:spPr>
         <p:txBody>
-          <a:bodyPr xmlns:a="http://schemas.openxmlformats.org/drawingml/2006/main" wrap="square" lIns="0" tIns="0" rIns="0" bIns="0" anchor="t">
+          <a:bodyPr xmlns:a="http://schemas.openxmlformats.org/drawingml/2006/main" wrap="square" lIns="95250" tIns="28575" rIns="95250" bIns="0" anchor="t">
             <a:noAutofit/>
           </a:bodyPr>
           <a:lstStyle xmlns:a="http://schemas.openxmlformats.org/drawingml/2006/main"/>
           <a:p xmlns:a="http://schemas.openxmlformats.org/drawingml/2006/main">
             <a:pPr>
               <a:buNone/>
-              <a:defRPr sz="1125" b="1">
-                <a:solidFill>
-                  <a:srgbClr val="EDBF9A"/>
+              <a:defRPr sz="1575" b="1">
+                <a:solidFill>
+                  <a:srgbClr val="154F43"/>
                 </a:solidFill>
                 <a:latin typeface="Arial"/>
                 <a:ea typeface="Arial"/>
@@ -1276,15 +1283,15 @@
               </a:defRPr>
             </a:pPr>
             <a:r>
-              <a:rPr sz="1125" b="1">
-                <a:solidFill>
-                  <a:srgbClr val="EDBF9A"/>
+              <a:rPr sz="1575" b="1">
+                <a:solidFill>
+                  <a:srgbClr val="154F43"/>
                 </a:solidFill>
                 <a:latin typeface="Arial"/>
                 <a:ea typeface="Arial"/>
                 <a:cs typeface="Arial"/>
               </a:rPr>
-              <a:t>STUDENT INTEREST</a:t>
+              <a:t>STUDENTS WILL RECEIVE COMPENSATION</a:t>
             </a:r>
           </a:p>
         </p:txBody>
@@ -2500,7 +2507,7 @@
                 <a:latin typeface="Arial"/>
                 <a:ea typeface="Arial"/>
                 <a:cs typeface="Arial"/>
-                <a:hlinkClick xmlns:r="http://schemas.openxmlformats.org/officeDocument/2006/relationships" r:id="Rdcfcaef8cda84794"/>
+                <a:hlinkClick xmlns:r="http://schemas.openxmlformats.org/officeDocument/2006/relationships" r:id="Rd1d1a2b5646b4881"/>
               </a:rPr>
               <a:t>forms.gle/13iPUM7vkB7HX4tK8</a:t>
             </a:r>
@@ -2516,7 +2523,7 @@
           <p:nvPr/>
         </p:nvPicPr>
         <p:blipFill>
-          <a:blip xmlns:r="http://schemas.openxmlformats.org/officeDocument/2006/relationships" xmlns:a="http://schemas.openxmlformats.org/drawingml/2006/main" r:embed="R0774efbd83d6482d"/>
+          <a:blip xmlns:r="http://schemas.openxmlformats.org/officeDocument/2006/relationships" xmlns:a="http://schemas.openxmlformats.org/drawingml/2006/main" r:embed="R6dc4d99d19b848e4"/>
           <a:stretch xmlns:a="http://schemas.openxmlformats.org/drawingml/2006/main"/>
         </p:blipFill>
         <p:spPr>
@@ -2582,7 +2589,7 @@
                 <a:ea typeface="Arial"/>
                 <a:cs typeface="Arial"/>
               </a:rPr>
-              <a:t>Expression of interest only; enrollment is not confirmed.</a:t>
+              <a:t>Compensation for confirmed participants. Interest form is not enrollment.</a:t>
             </a:r>
           </a:p>
         </p:txBody>
@@ -2640,7 +2647,7 @@
                 <a:ea typeface="Arial"/>
                 <a:cs typeface="Arial"/>
               </a:rPr>
-              <a:t>DRAFT · Dates, eligibility, and participant support are being finalized.</a:t>
+              <a:t>DRAFT · Dates, eligibility, and compensation details to be announced.</a:t>
             </a:r>
           </a:p>
         </p:txBody>
@@ -2654,7 +2661,7 @@
           <p:nvPr/>
         </p:nvPicPr>
         <p:blipFill>
-          <a:blip xmlns:r="http://schemas.openxmlformats.org/officeDocument/2006/relationships" xmlns:a="http://schemas.openxmlformats.org/drawingml/2006/main" r:embed="R7c121bb05d694db4"/>
+          <a:blip xmlns:r="http://schemas.openxmlformats.org/officeDocument/2006/relationships" xmlns:a="http://schemas.openxmlformats.org/drawingml/2006/main" r:embed="R3ac317f64c9947fa"/>
           <a:stretch xmlns:a="http://schemas.openxmlformats.org/drawingml/2006/main"/>
         </p:blipFill>
         <p:spPr>

</xml_diff>

<commit_message>
Focus recruitment website and poster on CyberTraining Workshops
</commit_message>
<xml_diff>
--- a/poster/NEXABio-student-interest.pptx
+++ b/poster/NEXABio-student-interest.pptx
@@ -2,13 +2,13 @@
 <file path=ppt/presentation.xml><?xml version="1.0" encoding="utf-8"?>
 <p:presentation xmlns:p="http://schemas.openxmlformats.org/presentationml/2006/main">
   <p:sldMasterIdLst>
-    <p:sldMasterId xmlns:r="http://schemas.openxmlformats.org/officeDocument/2006/relationships" id="2147483648" r:id="R2aceffb5dfba4645"/>
+    <p:sldMasterId xmlns:r="http://schemas.openxmlformats.org/officeDocument/2006/relationships" id="2147483648" r:id="Re73478f4dbb74b8a"/>
   </p:sldMasterIdLst>
   <p:notesMasterIdLst>
-    <p:notesMasterId xmlns:r="http://schemas.openxmlformats.org/officeDocument/2006/relationships" r:id="Re3eeba5affea4cbd"/>
+    <p:notesMasterId xmlns:r="http://schemas.openxmlformats.org/officeDocument/2006/relationships" r:id="R6448aa4387614b7c"/>
   </p:notesMasterIdLst>
   <p:sldIdLst>
-    <p:sldId xmlns:r="http://schemas.openxmlformats.org/officeDocument/2006/relationships" id="256" r:id="Ra86a95f9e3674f7a"/>
+    <p:sldId xmlns:r="http://schemas.openxmlformats.org/officeDocument/2006/relationships" id="256" r:id="R22770c07f28346c2"/>
   </p:sldIdLst>
   <p:sldSz cx="7772400" cy="10058400"/>
   <p:notesSz cx="6858000" cy="9144000"/>
@@ -485,6 +485,16 @@
               <a:t/>
             </a:r>
           </a:p>
+          <a:p xmlns:a="http://schemas.openxmlformats.org/drawingml/2006/main">
+            <a:r>
+              <a:t/>
+            </a:r>
+          </a:p>
+          <a:p xmlns:a="http://schemas.openxmlformats.org/drawingml/2006/main">
+            <a:r>
+              <a:t>Current recruitment scope: CyberTraining Workshops only, following project-team feedback.</a:t>
+            </a:r>
+          </a:p>
         </p:txBody>
       </p:sp>
       <p:sp>
@@ -550,7 +560,7 @@
   </p:cSld>
   <p:clrMap bg1="lt1" tx1="dk1" bg2="lt2" tx2="dk2" accent1="accent1" accent2="accent2" accent3="accent3" accent4="accent4" accent5="accent5" accent6="accent6" hlink="hlink" folHlink="folHlink"/>
   <p:sldLayoutIdLst>
-    <p:sldLayoutId xmlns:r="http://schemas.openxmlformats.org/officeDocument/2006/relationships" id="2147483649" r:id="R70c6868917a6477e"/>
+    <p:sldLayoutId xmlns:r="http://schemas.openxmlformats.org/officeDocument/2006/relationships" id="2147483649" r:id="R7094bdfb8cf54e3a"/>
   </p:sldLayoutIdLst>
   <p:txStyles>
     <p:titleStyle>
@@ -1165,7 +1175,7 @@
           <p:nvPr/>
         </p:nvPicPr>
         <p:blipFill>
-          <a:blip xmlns:r="http://schemas.openxmlformats.org/officeDocument/2006/relationships" xmlns:a="http://schemas.openxmlformats.org/drawingml/2006/main" r:embed="Re1a1883fe37c456c"/>
+          <a:blip xmlns:r="http://schemas.openxmlformats.org/officeDocument/2006/relationships" xmlns:a="http://schemas.openxmlformats.org/drawingml/2006/main" r:embed="R7196b2ce42e34790"/>
           <a:stretch xmlns:a="http://schemas.openxmlformats.org/drawingml/2006/main"/>
         </p:blipFill>
         <p:spPr>
@@ -1431,7 +1441,7 @@
                 <a:ea typeface="Arial"/>
                 <a:cs typeface="Arial"/>
               </a:rPr>
-              <a:t>Connect machine learning, scientific computing, and biomaterials through practical training and collaborative projects.</a:t>
+              <a:t>Join CyberTraining Workshops in AI, scientific computing, and biomaterials through hands-on exercises and team projects.</a:t>
             </a:r>
           </a:p>
         </p:txBody>
@@ -1606,7 +1616,7 @@
                 <a:ea typeface="Arial"/>
                 <a:cs typeface="Arial"/>
               </a:rPr>
-              <a:t>Three ways to learn and connect</a:t>
+              <a:t>CyberTraining Workshops</a:t>
             </a:r>
           </a:p>
         </p:txBody>
@@ -1694,7 +1704,7 @@
                 <a:ea typeface="Arial"/>
                 <a:cs typeface="Arial"/>
               </a:rPr>
-              <a:t>Workshops</a:t>
+              <a:t>Guided coding</a:t>
             </a:r>
           </a:p>
         </p:txBody>
@@ -1752,7 +1762,7 @@
                 <a:ea typeface="Arial"/>
                 <a:cs typeface="Arial"/>
               </a:rPr>
-              <a:t>Guided coding and</a:t>
+              <a:t>Practice scientific</a:t>
             </a:r>
           </a:p>
           <a:p xmlns:a="http://schemas.openxmlformats.org/drawingml/2006/main">
@@ -1776,7 +1786,7 @@
                 <a:ea typeface="Arial"/>
                 <a:cs typeface="Arial"/>
               </a:rPr>
-              <a:t>hands-on mini-projects</a:t>
+              <a:t>computing and AI methods</a:t>
             </a:r>
           </a:p>
         </p:txBody>
@@ -1864,7 +1874,7 @@
                 <a:ea typeface="Arial"/>
                 <a:cs typeface="Arial"/>
               </a:rPr>
-              <a:t>Summer bootcamp</a:t>
+              <a:t>Biomaterials data</a:t>
             </a:r>
           </a:p>
         </p:txBody>
@@ -1922,7 +1932,7 @@
                 <a:ea typeface="Arial"/>
                 <a:cs typeface="Arial"/>
               </a:rPr>
-              <a:t>An online introduction to</a:t>
+              <a:t>Work with real datasets</a:t>
             </a:r>
           </a:p>
           <a:p xmlns:a="http://schemas.openxmlformats.org/drawingml/2006/main">
@@ -1946,7 +1956,7 @@
                 <a:ea typeface="Arial"/>
                 <a:cs typeface="Arial"/>
               </a:rPr>
-              <a:t>AI-enabled biomaterials</a:t>
+              <a:t>and research questions</a:t>
             </a:r>
           </a:p>
         </p:txBody>
@@ -2034,7 +2044,7 @@
                 <a:ea typeface="Arial"/>
                 <a:cs typeface="Arial"/>
               </a:rPr>
-              <a:t>Invited talks</a:t>
+              <a:t>Team mini-projects</a:t>
             </a:r>
           </a:p>
         </p:txBody>
@@ -2092,7 +2102,7 @@
                 <a:ea typeface="Arial"/>
                 <a:cs typeface="Arial"/>
               </a:rPr>
-              <a:t>Research perspectives</a:t>
+              <a:t>Connect computational</a:t>
             </a:r>
           </a:p>
           <a:p xmlns:a="http://schemas.openxmlformats.org/drawingml/2006/main">
@@ -2116,7 +2126,7 @@
                 <a:ea typeface="Arial"/>
                 <a:cs typeface="Arial"/>
               </a:rPr>
-              <a:t>across AI and biomaterials</a:t>
+              <a:t>methods with experiments</a:t>
             </a:r>
           </a:p>
         </p:txBody>
@@ -2507,7 +2517,7 @@
                 <a:latin typeface="Arial"/>
                 <a:ea typeface="Arial"/>
                 <a:cs typeface="Arial"/>
-                <a:hlinkClick xmlns:r="http://schemas.openxmlformats.org/officeDocument/2006/relationships" r:id="Rd1d1a2b5646b4881"/>
+                <a:hlinkClick xmlns:r="http://schemas.openxmlformats.org/officeDocument/2006/relationships" r:id="Raae1ae5cb54f4876"/>
               </a:rPr>
               <a:t>forms.gle/13iPUM7vkB7HX4tK8</a:t>
             </a:r>
@@ -2523,7 +2533,7 @@
           <p:nvPr/>
         </p:nvPicPr>
         <p:blipFill>
-          <a:blip xmlns:r="http://schemas.openxmlformats.org/officeDocument/2006/relationships" xmlns:a="http://schemas.openxmlformats.org/drawingml/2006/main" r:embed="R6dc4d99d19b848e4"/>
+          <a:blip xmlns:r="http://schemas.openxmlformats.org/officeDocument/2006/relationships" xmlns:a="http://schemas.openxmlformats.org/drawingml/2006/main" r:embed="R92f9d825ef32419c"/>
           <a:stretch xmlns:a="http://schemas.openxmlformats.org/drawingml/2006/main"/>
         </p:blipFill>
         <p:spPr>
@@ -2661,7 +2671,7 @@
           <p:nvPr/>
         </p:nvPicPr>
         <p:blipFill>
-          <a:blip xmlns:r="http://schemas.openxmlformats.org/officeDocument/2006/relationships" xmlns:a="http://schemas.openxmlformats.org/drawingml/2006/main" r:embed="R3ac317f64c9947fa"/>
+          <a:blip xmlns:r="http://schemas.openxmlformats.org/officeDocument/2006/relationships" xmlns:a="http://schemas.openxmlformats.org/drawingml/2006/main" r:embed="R5bfb4f1d94e44d10"/>
           <a:stretch xmlns:a="http://schemas.openxmlformats.org/drawingml/2006/main"/>
         </p:blipFill>
         <p:spPr>

</xml_diff>